<commit_message>
Add Bagging step, time-series applicability note, and text-dump helper
- Notebook: new Bagging (bootstrap aggregating) section between the tuned
  Decision Tree and the Random Forest, with and without class-weighted base
  trees, plus a note on why time-series methods do not apply to this data
- Report and slides: bagging rows in the comparison tables and chart, wording
  updated to walk from one tree to bagging to a forest
- scripts/dump_text.py: plain-text dumps of the three deliverables for review

Co-Authored-By: Claude Fable 5.1 <noreply@anthropic.com>
Claude-Session: https://claude.ai/code/session_013FziBHdvbXYQwd5XRG4tZw
</commit_message>
<xml_diff>
--- a/presentation/Loan_Default_Prediction_Presentation.pptx
+++ b/presentation/Loan_Default_Prediction_Presentation.pptx
@@ -125,26 +125,26 @@
   <p:extLst>
     <p:ext uri="{521415D9-36F7-43E2-AB2F-B90AF26B5E84}">
       <p14:sectionLst xmlns:p14="http://schemas.microsoft.com/office/powerpoint/2010/main">
-        <p14:section name="Opening" id="{152c0ab4-0bc8-6677-17e8-38b932571b62}">
+        <p14:section name="Opening" id="{94860cd5-43ef-ee06-8049-37938167717a}">
           <p14:sldIdLst>
             <p14:sldId id="256"/>
             <p14:sldId id="257"/>
           </p14:sldIdLst>
         </p14:section>
-        <p14:section name="Problem and approach" id="{e81247c5-6dd3-30b9-22e4-21c35800f832}">
+        <p14:section name="Problem and approach" id="{b8e3ba4e-2566-0604-1b7c-1bf7fa7a922a}">
           <p14:sldIdLst>
             <p14:sldId id="258"/>
             <p14:sldId id="259"/>
           </p14:sldIdLst>
         </p14:section>
-        <p14:section name="Key insights" id="{cc135e1d-a26e-e379-35c0-a57e916115ab}">
+        <p14:section name="Key insights" id="{062fa8cf-80e6-52a2-5522-4a9b3c374866}">
           <p14:sldIdLst>
             <p14:sldId id="260"/>
             <p14:sldId id="261"/>
             <p14:sldId id="262"/>
           </p14:sldIdLst>
         </p14:section>
-        <p14:section name="Modelling" id="{7c36050b-0630-9c48-a285-dd5d63cb8f55}">
+        <p14:section name="Modelling" id="{ad2a4126-587f-a781-e790-e4f86936d131}">
           <p14:sldIdLst>
             <p14:sldId id="263"/>
             <p14:sldId id="264"/>
@@ -152,7 +152,7 @@
             <p14:sldId id="266"/>
           </p14:sldIdLst>
         </p14:section>
-        <p14:section name="Recommendations" id="{59cc9aa2-bac2-31c6-6279-d0c8237782ce}">
+        <p14:section name="Recommendations" id="{44a977be-9c89-7117-8ac5-43238303b891}">
           <p14:sldIdLst>
             <p14:sldId id="267"/>
             <p14:sldId id="268"/>
@@ -160,7 +160,7 @@
             <p14:sldId id="270"/>
           </p14:sldIdLst>
         </p14:section>
-        <p14:section name="Appendix" id="{37d195e6-c4e2-19f7-9fa1-7afed4aece6d}">
+        <p14:section name="Appendix" id="{3a967d96-123c-ed07-9e28-a66ad70eae32}">
           <p14:sldIdLst>
             <p14:sldId id="271"/>
             <p14:sldId id="272"/>
@@ -2129,9 +2129,9 @@
           </c:dLbls>
           <c:cat>
             <c:multiLvlStrRef>
-              <c:f>Sheet1!$A$2:$A$6</c:f>
+              <c:f>Sheet1!$A$2:$A$7</c:f>
               <c:multiLvlStrCache>
-                <c:ptCount val="5"/>
+                <c:ptCount val="6"/>
                 <c:lvl>
                   <c:pt idx="0">
                     <c:v>Logistic Regression (balanced)</c:v>
@@ -2140,12 +2140,15 @@
                     <c:v>Decision Tree (tuned)</c:v>
                   </c:pt>
                   <c:pt idx="2">
+                    <c:v>Bagged trees (200)</c:v>
+                  </c:pt>
+                  <c:pt idx="3">
                     <c:v>Random Forest (default)</c:v>
                   </c:pt>
-                  <c:pt idx="3">
+                  <c:pt idx="4">
                     <c:v>Random Forest (class weights)</c:v>
                   </c:pt>
-                  <c:pt idx="4">
+                  <c:pt idx="5">
                     <c:v>Random Forest, threshold 0.25</c:v>
                   </c:pt>
                 </c:lvl>
@@ -2154,10 +2157,10 @@
           </c:cat>
           <c:val>
             <c:numRef>
-              <c:f>Sheet1!$B$2:$B$6</c:f>
+              <c:f>Sheet1!$B$2:$B$7</c:f>
               <c:numCache>
                 <c:formatCode>General</c:formatCode>
-                <c:ptCount val="5"/>
+                <c:ptCount val="6"/>
                 <c:pt idx="0">
                   <c:v>79.8</c:v>
                 </c:pt>
@@ -2165,12 +2168,15 @@
                   <c:v>81.8</c:v>
                 </c:pt>
                 <c:pt idx="2">
+                  <c:v>67.8</c:v>
+                </c:pt>
+                <c:pt idx="3">
                   <c:v>68.9</c:v>
                 </c:pt>
-                <c:pt idx="3">
+                <c:pt idx="4">
                   <c:v>78.4</c:v>
                 </c:pt>
-                <c:pt idx="4">
+                <c:pt idx="5">
                   <c:v>93.3</c:v>
                 </c:pt>
               </c:numCache>
@@ -2224,9 +2230,9 @@
           </c:dLbls>
           <c:cat>
             <c:multiLvlStrRef>
-              <c:f>Sheet1!$A$2:$A$6</c:f>
+              <c:f>Sheet1!$A$2:$A$7</c:f>
               <c:multiLvlStrCache>
-                <c:ptCount val="5"/>
+                <c:ptCount val="6"/>
                 <c:lvl>
                   <c:pt idx="0">
                     <c:v>Logistic Regression (balanced)</c:v>
@@ -2235,12 +2241,15 @@
                     <c:v>Decision Tree (tuned)</c:v>
                   </c:pt>
                   <c:pt idx="2">
+                    <c:v>Bagged trees (200)</c:v>
+                  </c:pt>
+                  <c:pt idx="3">
                     <c:v>Random Forest (default)</c:v>
                   </c:pt>
-                  <c:pt idx="3">
+                  <c:pt idx="4">
                     <c:v>Random Forest (class weights)</c:v>
                   </c:pt>
-                  <c:pt idx="4">
+                  <c:pt idx="5">
                     <c:v>Random Forest, threshold 0.25</c:v>
                   </c:pt>
                 </c:lvl>
@@ -2249,10 +2258,10 @@
           </c:cat>
           <c:val>
             <c:numRef>
-              <c:f>Sheet1!$C$2:$C$6</c:f>
+              <c:f>Sheet1!$C$2:$C$7</c:f>
               <c:numCache>
                 <c:formatCode>General</c:formatCode>
-                <c:ptCount val="5"/>
+                <c:ptCount val="6"/>
                 <c:pt idx="0">
                   <c:v>61.2</c:v>
                 </c:pt>
@@ -2260,12 +2269,15 @@
                   <c:v>53.3</c:v>
                 </c:pt>
                 <c:pt idx="2">
+                  <c:v>82.6</c:v>
+                </c:pt>
+                <c:pt idx="3">
                   <c:v>84.5</c:v>
                 </c:pt>
-                <c:pt idx="3">
+                <c:pt idx="4">
                   <c:v>77.3</c:v>
                 </c:pt>
-                <c:pt idx="4">
+                <c:pt idx="5">
                   <c:v>67</c:v>
                 </c:pt>
               </c:numCache>
@@ -9970,7 +9982,7 @@
                 <a:gridCol w="868680"/>
                 <a:gridCol w="868680"/>
               </a:tblGrid>
-              <a:tr h="301752">
+              <a:tr h="274320">
                 <a:tc>
                   <a:txBody>
                     <a:bodyPr/>
@@ -9980,7 +9992,7 @@
                         <a:buNone/>
                       </a:pPr>
                       <a:r>
-                        <a:rPr lang="en-US" sz="1050" b="1" dirty="0">
+                        <a:rPr lang="en-US" sz="1000" b="1" dirty="0">
                           <a:solidFill>
                             <a:srgbClr val="FFFFFF"/>
                           </a:solidFill>
@@ -9990,14 +10002,14 @@
                         </a:rPr>
                         <a:t>Model</a:t>
                       </a:r>
-                      <a:endParaRPr lang="en-US" sz="1050" dirty="0">
+                      <a:endParaRPr lang="en-US" sz="1000" dirty="0">
                         <a:latin typeface="Calibri" charset="0"/>
                         <a:ea typeface="Calibri" charset="0"/>
                         <a:cs typeface="Calibri" charset="0"/>
                       </a:endParaRPr>
                     </a:p>
                   </a:txBody>
-                  <a:tcPr marL="36576" marR="36576" marT="36576" marB="36576" anchor="ctr">
+                  <a:tcPr marL="27432" marR="27432" marT="27432" marB="27432" anchor="ctr">
                     <a:lnL w="6350" cap="flat" cmpd="sng" algn="ctr">
                       <a:solidFill>
                         <a:srgbClr val="BFBFBF"/>
@@ -10048,7 +10060,7 @@
                         <a:buNone/>
                       </a:pPr>
                       <a:r>
-                        <a:rPr lang="en-US" sz="1050" b="1" dirty="0">
+                        <a:rPr lang="en-US" sz="1000" b="1" dirty="0">
                           <a:solidFill>
                             <a:srgbClr val="FFFFFF"/>
                           </a:solidFill>
@@ -10058,14 +10070,14 @@
                         </a:rPr>
                         <a:t>Recall</a:t>
                       </a:r>
-                      <a:endParaRPr lang="en-US" sz="1050" dirty="0">
+                      <a:endParaRPr lang="en-US" sz="1000" dirty="0">
                         <a:latin typeface="Calibri" charset="0"/>
                         <a:ea typeface="Calibri" charset="0"/>
                         <a:cs typeface="Calibri" charset="0"/>
                       </a:endParaRPr>
                     </a:p>
                   </a:txBody>
-                  <a:tcPr marL="36576" marR="36576" marT="36576" marB="36576" anchor="ctr">
+                  <a:tcPr marL="27432" marR="27432" marT="27432" marB="27432" anchor="ctr">
                     <a:lnL w="6350" cap="flat" cmpd="sng" algn="ctr">
                       <a:solidFill>
                         <a:srgbClr val="BFBFBF"/>
@@ -10116,7 +10128,7 @@
                         <a:buNone/>
                       </a:pPr>
                       <a:r>
-                        <a:rPr lang="en-US" sz="1050" b="1" dirty="0">
+                        <a:rPr lang="en-US" sz="1000" b="1" dirty="0">
                           <a:solidFill>
                             <a:srgbClr val="FFFFFF"/>
                           </a:solidFill>
@@ -10126,14 +10138,14 @@
                         </a:rPr>
                         <a:t>Precision</a:t>
                       </a:r>
-                      <a:endParaRPr lang="en-US" sz="1050" dirty="0">
+                      <a:endParaRPr lang="en-US" sz="1000" dirty="0">
                         <a:latin typeface="Calibri" charset="0"/>
                         <a:ea typeface="Calibri" charset="0"/>
                         <a:cs typeface="Calibri" charset="0"/>
                       </a:endParaRPr>
                     </a:p>
                   </a:txBody>
-                  <a:tcPr marL="36576" marR="36576" marT="36576" marB="36576" anchor="ctr">
+                  <a:tcPr marL="27432" marR="27432" marT="27432" marB="27432" anchor="ctr">
                     <a:lnL w="6350" cap="flat" cmpd="sng" algn="ctr">
                       <a:solidFill>
                         <a:srgbClr val="BFBFBF"/>
@@ -10184,7 +10196,7 @@
                         <a:buNone/>
                       </a:pPr>
                       <a:r>
-                        <a:rPr lang="en-US" sz="1050" b="1" dirty="0">
+                        <a:rPr lang="en-US" sz="1000" b="1" dirty="0">
                           <a:solidFill>
                             <a:srgbClr val="FFFFFF"/>
                           </a:solidFill>
@@ -10194,14 +10206,14 @@
                         </a:rPr>
                         <a:t>F1</a:t>
                       </a:r>
-                      <a:endParaRPr lang="en-US" sz="1050" dirty="0">
+                      <a:endParaRPr lang="en-US" sz="1000" dirty="0">
                         <a:latin typeface="Calibri" charset="0"/>
                         <a:ea typeface="Calibri" charset="0"/>
                         <a:cs typeface="Calibri" charset="0"/>
                       </a:endParaRPr>
                     </a:p>
                   </a:txBody>
-                  <a:tcPr marL="36576" marR="36576" marT="36576" marB="36576" anchor="ctr">
+                  <a:tcPr marL="27432" marR="27432" marT="27432" marB="27432" anchor="ctr">
                     <a:lnL w="6350" cap="flat" cmpd="sng" algn="ctr">
                       <a:solidFill>
                         <a:srgbClr val="BFBFBF"/>
@@ -10252,7 +10264,7 @@
                         <a:buNone/>
                       </a:pPr>
                       <a:r>
-                        <a:rPr lang="en-US" sz="1050" b="1" dirty="0">
+                        <a:rPr lang="en-US" sz="1000" b="1" dirty="0">
                           <a:solidFill>
                             <a:srgbClr val="FFFFFF"/>
                           </a:solidFill>
@@ -10262,14 +10274,14 @@
                         </a:rPr>
                         <a:t>Accuracy</a:t>
                       </a:r>
-                      <a:endParaRPr lang="en-US" sz="1050" dirty="0">
+                      <a:endParaRPr lang="en-US" sz="1000" dirty="0">
                         <a:latin typeface="Calibri" charset="0"/>
                         <a:ea typeface="Calibri" charset="0"/>
                         <a:cs typeface="Calibri" charset="0"/>
                       </a:endParaRPr>
                     </a:p>
                   </a:txBody>
-                  <a:tcPr marL="36576" marR="36576" marT="36576" marB="36576" anchor="ctr">
+                  <a:tcPr marL="27432" marR="27432" marT="27432" marB="27432" anchor="ctr">
                     <a:lnL w="6350" cap="flat" cmpd="sng" algn="ctr">
                       <a:solidFill>
                         <a:srgbClr val="BFBFBF"/>
@@ -10320,7 +10332,7 @@
                         <a:buNone/>
                       </a:pPr>
                       <a:r>
-                        <a:rPr lang="en-US" sz="1050" b="1" dirty="0">
+                        <a:rPr lang="en-US" sz="1000" b="1" dirty="0">
                           <a:solidFill>
                             <a:srgbClr val="FFFFFF"/>
                           </a:solidFill>
@@ -10330,14 +10342,14 @@
                         </a:rPr>
                         <a:t>ROC-AUC</a:t>
                       </a:r>
-                      <a:endParaRPr lang="en-US" sz="1050" dirty="0">
+                      <a:endParaRPr lang="en-US" sz="1000" dirty="0">
                         <a:latin typeface="Calibri" charset="0"/>
                         <a:ea typeface="Calibri" charset="0"/>
                         <a:cs typeface="Calibri" charset="0"/>
                       </a:endParaRPr>
                     </a:p>
                   </a:txBody>
-                  <a:tcPr marL="36576" marR="36576" marT="36576" marB="36576" anchor="ctr">
+                  <a:tcPr marL="27432" marR="27432" marT="27432" marB="27432" anchor="ctr">
                     <a:lnL w="6350" cap="flat" cmpd="sng" algn="ctr">
                       <a:solidFill>
                         <a:srgbClr val="BFBFBF"/>
@@ -10388,7 +10400,7 @@
                         <a:buNone/>
                       </a:pPr>
                       <a:r>
-                        <a:rPr lang="en-US" sz="1050" b="1" dirty="0">
+                        <a:rPr lang="en-US" sz="1000" b="1" dirty="0">
                           <a:solidFill>
                             <a:srgbClr val="FFFFFF"/>
                           </a:solidFill>
@@ -10398,14 +10410,14 @@
                         </a:rPr>
                         <a:t>Train recall</a:t>
                       </a:r>
-                      <a:endParaRPr lang="en-US" sz="1050" dirty="0">
+                      <a:endParaRPr lang="en-US" sz="1000" dirty="0">
                         <a:latin typeface="Calibri" charset="0"/>
                         <a:ea typeface="Calibri" charset="0"/>
                         <a:cs typeface="Calibri" charset="0"/>
                       </a:endParaRPr>
                     </a:p>
                   </a:txBody>
-                  <a:tcPr marL="36576" marR="36576" marT="36576" marB="36576" anchor="ctr">
+                  <a:tcPr marL="27432" marR="27432" marT="27432" marB="27432" anchor="ctr">
                     <a:lnL w="6350" cap="flat" cmpd="sng" algn="ctr">
                       <a:solidFill>
                         <a:srgbClr val="BFBFBF"/>
@@ -10448,7 +10460,7 @@
                   </a:tcPr>
                 </a:tc>
               </a:tr>
-              <a:tr h="301752">
+              <a:tr h="274320">
                 <a:tc>
                   <a:txBody>
                     <a:bodyPr/>
@@ -10458,7 +10470,7 @@
                         <a:buNone/>
                       </a:pPr>
                       <a:r>
-                        <a:rPr lang="en-US" sz="1050" dirty="0">
+                        <a:rPr lang="en-US" sz="1000" dirty="0">
                           <a:solidFill>
                             <a:srgbClr val="1F1F1F"/>
                           </a:solidFill>
@@ -10468,14 +10480,14 @@
                         </a:rPr>
                         <a:t>Logistic Regression (plain)</a:t>
                       </a:r>
-                      <a:endParaRPr lang="en-US" sz="1050" dirty="0">
+                      <a:endParaRPr lang="en-US" sz="1000" dirty="0">
                         <a:latin typeface="Calibri" charset="0"/>
                         <a:ea typeface="Calibri" charset="0"/>
                         <a:cs typeface="Calibri" charset="0"/>
                       </a:endParaRPr>
                     </a:p>
                   </a:txBody>
-                  <a:tcPr marL="36576" marR="36576" marT="36576" marB="36576" anchor="ctr">
+                  <a:tcPr marL="27432" marR="27432" marT="27432" marB="27432" anchor="ctr">
                     <a:lnL w="6350" cap="flat" cmpd="sng" algn="ctr">
                       <a:solidFill>
                         <a:srgbClr val="BFBFBF"/>
@@ -10523,7 +10535,7 @@
                         <a:buNone/>
                       </a:pPr>
                       <a:r>
-                        <a:rPr lang="en-US" sz="1050" dirty="0">
+                        <a:rPr lang="en-US" sz="1000" dirty="0">
                           <a:solidFill>
                             <a:srgbClr val="1F1F1F"/>
                           </a:solidFill>
@@ -10533,14 +10545,14 @@
                         </a:rPr>
                         <a:t>0.569</a:t>
                       </a:r>
-                      <a:endParaRPr lang="en-US" sz="1050" dirty="0">
+                      <a:endParaRPr lang="en-US" sz="1000" dirty="0">
                         <a:latin typeface="Calibri" charset="0"/>
                         <a:ea typeface="Calibri" charset="0"/>
                         <a:cs typeface="Calibri" charset="0"/>
                       </a:endParaRPr>
                     </a:p>
                   </a:txBody>
-                  <a:tcPr marL="36576" marR="36576" marT="36576" marB="36576" anchor="ctr">
+                  <a:tcPr marL="27432" marR="27432" marT="27432" marB="27432" anchor="ctr">
                     <a:lnL w="6350" cap="flat" cmpd="sng" algn="ctr">
                       <a:solidFill>
                         <a:srgbClr val="BFBFBF"/>
@@ -10588,7 +10600,7 @@
                         <a:buNone/>
                       </a:pPr>
                       <a:r>
-                        <a:rPr lang="en-US" sz="1050" dirty="0">
+                        <a:rPr lang="en-US" sz="1000" dirty="0">
                           <a:solidFill>
                             <a:srgbClr val="1F1F1F"/>
                           </a:solidFill>
@@ -10598,14 +10610,14 @@
                         </a:rPr>
                         <a:t>0.772</a:t>
                       </a:r>
-                      <a:endParaRPr lang="en-US" sz="1050" dirty="0">
+                      <a:endParaRPr lang="en-US" sz="1000" dirty="0">
                         <a:latin typeface="Calibri" charset="0"/>
                         <a:ea typeface="Calibri" charset="0"/>
                         <a:cs typeface="Calibri" charset="0"/>
                       </a:endParaRPr>
                     </a:p>
                   </a:txBody>
-                  <a:tcPr marL="36576" marR="36576" marT="36576" marB="36576" anchor="ctr">
+                  <a:tcPr marL="27432" marR="27432" marT="27432" marB="27432" anchor="ctr">
                     <a:lnL w="6350" cap="flat" cmpd="sng" algn="ctr">
                       <a:solidFill>
                         <a:srgbClr val="BFBFBF"/>
@@ -10653,7 +10665,7 @@
                         <a:buNone/>
                       </a:pPr>
                       <a:r>
-                        <a:rPr lang="en-US" sz="1050" dirty="0">
+                        <a:rPr lang="en-US" sz="1000" dirty="0">
                           <a:solidFill>
                             <a:srgbClr val="1F1F1F"/>
                           </a:solidFill>
@@ -10663,14 +10675,14 @@
                         </a:rPr>
                         <a:t>0.655</a:t>
                       </a:r>
-                      <a:endParaRPr lang="en-US" sz="1050" dirty="0">
+                      <a:endParaRPr lang="en-US" sz="1000" dirty="0">
                         <a:latin typeface="Calibri" charset="0"/>
                         <a:ea typeface="Calibri" charset="0"/>
                         <a:cs typeface="Calibri" charset="0"/>
                       </a:endParaRPr>
                     </a:p>
                   </a:txBody>
-                  <a:tcPr marL="36576" marR="36576" marT="36576" marB="36576" anchor="ctr">
+                  <a:tcPr marL="27432" marR="27432" marT="27432" marB="27432" anchor="ctr">
                     <a:lnL w="6350" cap="flat" cmpd="sng" algn="ctr">
                       <a:solidFill>
                         <a:srgbClr val="BFBFBF"/>
@@ -10718,7 +10730,7 @@
                         <a:buNone/>
                       </a:pPr>
                       <a:r>
-                        <a:rPr lang="en-US" sz="1050" dirty="0">
+                        <a:rPr lang="en-US" sz="1000" dirty="0">
                           <a:solidFill>
                             <a:srgbClr val="1F1F1F"/>
                           </a:solidFill>
@@ -10728,14 +10740,14 @@
                         </a:rPr>
                         <a:t>0.880</a:t>
                       </a:r>
-                      <a:endParaRPr lang="en-US" sz="1050" dirty="0">
+                      <a:endParaRPr lang="en-US" sz="1000" dirty="0">
                         <a:latin typeface="Calibri" charset="0"/>
                         <a:ea typeface="Calibri" charset="0"/>
                         <a:cs typeface="Calibri" charset="0"/>
                       </a:endParaRPr>
                     </a:p>
                   </a:txBody>
-                  <a:tcPr marL="36576" marR="36576" marT="36576" marB="36576" anchor="ctr">
+                  <a:tcPr marL="27432" marR="27432" marT="27432" marB="27432" anchor="ctr">
                     <a:lnL w="6350" cap="flat" cmpd="sng" algn="ctr">
                       <a:solidFill>
                         <a:srgbClr val="BFBFBF"/>
@@ -10783,7 +10795,7 @@
                         <a:buNone/>
                       </a:pPr>
                       <a:r>
-                        <a:rPr lang="en-US" sz="1050" dirty="0">
+                        <a:rPr lang="en-US" sz="1000" dirty="0">
                           <a:solidFill>
                             <a:srgbClr val="1F1F1F"/>
                           </a:solidFill>
@@ -10793,14 +10805,14 @@
                         </a:rPr>
                         <a:t>0.907</a:t>
                       </a:r>
-                      <a:endParaRPr lang="en-US" sz="1050" dirty="0">
+                      <a:endParaRPr lang="en-US" sz="1000" dirty="0">
                         <a:latin typeface="Calibri" charset="0"/>
                         <a:ea typeface="Calibri" charset="0"/>
                         <a:cs typeface="Calibri" charset="0"/>
                       </a:endParaRPr>
                     </a:p>
                   </a:txBody>
-                  <a:tcPr marL="36576" marR="36576" marT="36576" marB="36576" anchor="ctr">
+                  <a:tcPr marL="27432" marR="27432" marT="27432" marB="27432" anchor="ctr">
                     <a:lnL w="6350" cap="flat" cmpd="sng" algn="ctr">
                       <a:solidFill>
                         <a:srgbClr val="BFBFBF"/>
@@ -10848,7 +10860,7 @@
                         <a:buNone/>
                       </a:pPr>
                       <a:r>
-                        <a:rPr lang="en-US" sz="1050" dirty="0">
+                        <a:rPr lang="en-US" sz="1000" dirty="0">
                           <a:solidFill>
                             <a:srgbClr val="1F1F1F"/>
                           </a:solidFill>
@@ -10858,14 +10870,14 @@
                         </a:rPr>
                         <a:t>0.643</a:t>
                       </a:r>
-                      <a:endParaRPr lang="en-US" sz="1050" dirty="0">
+                      <a:endParaRPr lang="en-US" sz="1000" dirty="0">
                         <a:latin typeface="Calibri" charset="0"/>
                         <a:ea typeface="Calibri" charset="0"/>
                         <a:cs typeface="Calibri" charset="0"/>
                       </a:endParaRPr>
                     </a:p>
                   </a:txBody>
-                  <a:tcPr marL="36576" marR="36576" marT="36576" marB="36576" anchor="ctr">
+                  <a:tcPr marL="27432" marR="27432" marT="27432" marB="27432" anchor="ctr">
                     <a:lnL w="6350" cap="flat" cmpd="sng" algn="ctr">
                       <a:solidFill>
                         <a:srgbClr val="BFBFBF"/>
@@ -10905,7 +10917,7 @@
                   </a:tcPr>
                 </a:tc>
               </a:tr>
-              <a:tr h="301752">
+              <a:tr h="274320">
                 <a:tc>
                   <a:txBody>
                     <a:bodyPr/>
@@ -10915,7 +10927,7 @@
                         <a:buNone/>
                       </a:pPr>
                       <a:r>
-                        <a:rPr lang="en-US" sz="1050" dirty="0">
+                        <a:rPr lang="en-US" sz="1000" dirty="0">
                           <a:solidFill>
                             <a:srgbClr val="1F1F1F"/>
                           </a:solidFill>
@@ -10925,14 +10937,14 @@
                         </a:rPr>
                         <a:t>Logistic Regression (balanced)</a:t>
                       </a:r>
-                      <a:endParaRPr lang="en-US" sz="1050" dirty="0">
+                      <a:endParaRPr lang="en-US" sz="1000" dirty="0">
                         <a:latin typeface="Calibri" charset="0"/>
                         <a:ea typeface="Calibri" charset="0"/>
                         <a:cs typeface="Calibri" charset="0"/>
                       </a:endParaRPr>
                     </a:p>
                   </a:txBody>
-                  <a:tcPr marL="36576" marR="36576" marT="36576" marB="36576" anchor="ctr">
+                  <a:tcPr marL="27432" marR="27432" marT="27432" marB="27432" anchor="ctr">
                     <a:lnL w="6350" cap="flat" cmpd="sng" algn="ctr">
                       <a:solidFill>
                         <a:srgbClr val="BFBFBF"/>
@@ -10980,7 +10992,7 @@
                         <a:buNone/>
                       </a:pPr>
                       <a:r>
-                        <a:rPr lang="en-US" sz="1050" dirty="0">
+                        <a:rPr lang="en-US" sz="1000" dirty="0">
                           <a:solidFill>
                             <a:srgbClr val="1F1F1F"/>
                           </a:solidFill>
@@ -10990,14 +11002,14 @@
                         </a:rPr>
                         <a:t>0.798</a:t>
                       </a:r>
-                      <a:endParaRPr lang="en-US" sz="1050" dirty="0">
+                      <a:endParaRPr lang="en-US" sz="1000" dirty="0">
                         <a:latin typeface="Calibri" charset="0"/>
                         <a:ea typeface="Calibri" charset="0"/>
                         <a:cs typeface="Calibri" charset="0"/>
                       </a:endParaRPr>
                     </a:p>
                   </a:txBody>
-                  <a:tcPr marL="36576" marR="36576" marT="36576" marB="36576" anchor="ctr">
+                  <a:tcPr marL="27432" marR="27432" marT="27432" marB="27432" anchor="ctr">
                     <a:lnL w="6350" cap="flat" cmpd="sng" algn="ctr">
                       <a:solidFill>
                         <a:srgbClr val="BFBFBF"/>
@@ -11045,7 +11057,7 @@
                         <a:buNone/>
                       </a:pPr>
                       <a:r>
-                        <a:rPr lang="en-US" sz="1050" dirty="0">
+                        <a:rPr lang="en-US" sz="1000" dirty="0">
                           <a:solidFill>
                             <a:srgbClr val="1F1F1F"/>
                           </a:solidFill>
@@ -11055,14 +11067,14 @@
                         </a:rPr>
                         <a:t>0.612</a:t>
                       </a:r>
-                      <a:endParaRPr lang="en-US" sz="1050" dirty="0">
+                      <a:endParaRPr lang="en-US" sz="1000" dirty="0">
                         <a:latin typeface="Calibri" charset="0"/>
                         <a:ea typeface="Calibri" charset="0"/>
                         <a:cs typeface="Calibri" charset="0"/>
                       </a:endParaRPr>
                     </a:p>
                   </a:txBody>
-                  <a:tcPr marL="36576" marR="36576" marT="36576" marB="36576" anchor="ctr">
+                  <a:tcPr marL="27432" marR="27432" marT="27432" marB="27432" anchor="ctr">
                     <a:lnL w="6350" cap="flat" cmpd="sng" algn="ctr">
                       <a:solidFill>
                         <a:srgbClr val="BFBFBF"/>
@@ -11110,7 +11122,7 @@
                         <a:buNone/>
                       </a:pPr>
                       <a:r>
-                        <a:rPr lang="en-US" sz="1050" dirty="0">
+                        <a:rPr lang="en-US" sz="1000" dirty="0">
                           <a:solidFill>
                             <a:srgbClr val="1F1F1F"/>
                           </a:solidFill>
@@ -11120,14 +11132,14 @@
                         </a:rPr>
                         <a:t>0.693</a:t>
                       </a:r>
-                      <a:endParaRPr lang="en-US" sz="1050" dirty="0">
+                      <a:endParaRPr lang="en-US" sz="1000" dirty="0">
                         <a:latin typeface="Calibri" charset="0"/>
                         <a:ea typeface="Calibri" charset="0"/>
                         <a:cs typeface="Calibri" charset="0"/>
                       </a:endParaRPr>
                     </a:p>
                   </a:txBody>
-                  <a:tcPr marL="36576" marR="36576" marT="36576" marB="36576" anchor="ctr">
+                  <a:tcPr marL="27432" marR="27432" marT="27432" marB="27432" anchor="ctr">
                     <a:lnL w="6350" cap="flat" cmpd="sng" algn="ctr">
                       <a:solidFill>
                         <a:srgbClr val="BFBFBF"/>
@@ -11175,7 +11187,7 @@
                         <a:buNone/>
                       </a:pPr>
                       <a:r>
-                        <a:rPr lang="en-US" sz="1050" dirty="0">
+                        <a:rPr lang="en-US" sz="1000" dirty="0">
                           <a:solidFill>
                             <a:srgbClr val="1F1F1F"/>
                           </a:solidFill>
@@ -11185,14 +11197,14 @@
                         </a:rPr>
                         <a:t>0.859</a:t>
                       </a:r>
-                      <a:endParaRPr lang="en-US" sz="1050" dirty="0">
+                      <a:endParaRPr lang="en-US" sz="1000" dirty="0">
                         <a:latin typeface="Calibri" charset="0"/>
                         <a:ea typeface="Calibri" charset="0"/>
                         <a:cs typeface="Calibri" charset="0"/>
                       </a:endParaRPr>
                     </a:p>
                   </a:txBody>
-                  <a:tcPr marL="36576" marR="36576" marT="36576" marB="36576" anchor="ctr">
+                  <a:tcPr marL="27432" marR="27432" marT="27432" marB="27432" anchor="ctr">
                     <a:lnL w="6350" cap="flat" cmpd="sng" algn="ctr">
                       <a:solidFill>
                         <a:srgbClr val="BFBFBF"/>
@@ -11240,7 +11252,7 @@
                         <a:buNone/>
                       </a:pPr>
                       <a:r>
-                        <a:rPr lang="en-US" sz="1050" dirty="0">
+                        <a:rPr lang="en-US" sz="1000" dirty="0">
                           <a:solidFill>
                             <a:srgbClr val="1F1F1F"/>
                           </a:solidFill>
@@ -11250,14 +11262,14 @@
                         </a:rPr>
                         <a:t>0.906</a:t>
                       </a:r>
-                      <a:endParaRPr lang="en-US" sz="1050" dirty="0">
+                      <a:endParaRPr lang="en-US" sz="1000" dirty="0">
                         <a:latin typeface="Calibri" charset="0"/>
                         <a:ea typeface="Calibri" charset="0"/>
                         <a:cs typeface="Calibri" charset="0"/>
                       </a:endParaRPr>
                     </a:p>
                   </a:txBody>
-                  <a:tcPr marL="36576" marR="36576" marT="36576" marB="36576" anchor="ctr">
+                  <a:tcPr marL="27432" marR="27432" marT="27432" marB="27432" anchor="ctr">
                     <a:lnL w="6350" cap="flat" cmpd="sng" algn="ctr">
                       <a:solidFill>
                         <a:srgbClr val="BFBFBF"/>
@@ -11305,7 +11317,7 @@
                         <a:buNone/>
                       </a:pPr>
                       <a:r>
-                        <a:rPr lang="en-US" sz="1050" dirty="0">
+                        <a:rPr lang="en-US" sz="1000" dirty="0">
                           <a:solidFill>
                             <a:srgbClr val="1F1F1F"/>
                           </a:solidFill>
@@ -11315,14 +11327,14 @@
                         </a:rPr>
                         <a:t>0.823</a:t>
                       </a:r>
-                      <a:endParaRPr lang="en-US" sz="1050" dirty="0">
+                      <a:endParaRPr lang="en-US" sz="1000" dirty="0">
                         <a:latin typeface="Calibri" charset="0"/>
                         <a:ea typeface="Calibri" charset="0"/>
                         <a:cs typeface="Calibri" charset="0"/>
                       </a:endParaRPr>
                     </a:p>
                   </a:txBody>
-                  <a:tcPr marL="36576" marR="36576" marT="36576" marB="36576" anchor="ctr">
+                  <a:tcPr marL="27432" marR="27432" marT="27432" marB="27432" anchor="ctr">
                     <a:lnL w="6350" cap="flat" cmpd="sng" algn="ctr">
                       <a:solidFill>
                         <a:srgbClr val="BFBFBF"/>
@@ -11362,7 +11374,7 @@
                   </a:tcPr>
                 </a:tc>
               </a:tr>
-              <a:tr h="301752">
+              <a:tr h="274320">
                 <a:tc>
                   <a:txBody>
                     <a:bodyPr/>
@@ -11372,7 +11384,7 @@
                         <a:buNone/>
                       </a:pPr>
                       <a:r>
-                        <a:rPr lang="en-US" sz="1050" dirty="0">
+                        <a:rPr lang="en-US" sz="1000" dirty="0">
                           <a:solidFill>
                             <a:srgbClr val="1F1F1F"/>
                           </a:solidFill>
@@ -11382,14 +11394,14 @@
                         </a:rPr>
                         <a:t>Decision Tree (default)</a:t>
                       </a:r>
-                      <a:endParaRPr lang="en-US" sz="1050" dirty="0">
+                      <a:endParaRPr lang="en-US" sz="1000" dirty="0">
                         <a:latin typeface="Calibri" charset="0"/>
                         <a:ea typeface="Calibri" charset="0"/>
                         <a:cs typeface="Calibri" charset="0"/>
                       </a:endParaRPr>
                     </a:p>
                   </a:txBody>
-                  <a:tcPr marL="36576" marR="36576" marT="36576" marB="36576" anchor="ctr">
+                  <a:tcPr marL="27432" marR="27432" marT="27432" marB="27432" anchor="ctr">
                     <a:lnL w="6350" cap="flat" cmpd="sng" algn="ctr">
                       <a:solidFill>
                         <a:srgbClr val="BFBFBF"/>
@@ -11437,7 +11449,7 @@
                         <a:buNone/>
                       </a:pPr>
                       <a:r>
-                        <a:rPr lang="en-US" sz="1050" dirty="0">
+                        <a:rPr lang="en-US" sz="1000" dirty="0">
                           <a:solidFill>
                             <a:srgbClr val="1F1F1F"/>
                           </a:solidFill>
@@ -11447,14 +11459,14 @@
                         </a:rPr>
                         <a:t>0.686</a:t>
                       </a:r>
-                      <a:endParaRPr lang="en-US" sz="1050" dirty="0">
+                      <a:endParaRPr lang="en-US" sz="1000" dirty="0">
                         <a:latin typeface="Calibri" charset="0"/>
                         <a:ea typeface="Calibri" charset="0"/>
                         <a:cs typeface="Calibri" charset="0"/>
                       </a:endParaRPr>
                     </a:p>
                   </a:txBody>
-                  <a:tcPr marL="36576" marR="36576" marT="36576" marB="36576" anchor="ctr">
+                  <a:tcPr marL="27432" marR="27432" marT="27432" marB="27432" anchor="ctr">
                     <a:lnL w="6350" cap="flat" cmpd="sng" algn="ctr">
                       <a:solidFill>
                         <a:srgbClr val="BFBFBF"/>
@@ -11502,7 +11514,7 @@
                         <a:buNone/>
                       </a:pPr>
                       <a:r>
-                        <a:rPr lang="en-US" sz="1050" dirty="0">
+                        <a:rPr lang="en-US" sz="1000" dirty="0">
                           <a:solidFill>
                             <a:srgbClr val="1F1F1F"/>
                           </a:solidFill>
@@ -11512,14 +11524,14 @@
                         </a:rPr>
                         <a:t>0.706</a:t>
                       </a:r>
-                      <a:endParaRPr lang="en-US" sz="1050" dirty="0">
+                      <a:endParaRPr lang="en-US" sz="1000" dirty="0">
                         <a:latin typeface="Calibri" charset="0"/>
                         <a:ea typeface="Calibri" charset="0"/>
                         <a:cs typeface="Calibri" charset="0"/>
                       </a:endParaRPr>
                     </a:p>
                   </a:txBody>
-                  <a:tcPr marL="36576" marR="36576" marT="36576" marB="36576" anchor="ctr">
+                  <a:tcPr marL="27432" marR="27432" marT="27432" marB="27432" anchor="ctr">
                     <a:lnL w="6350" cap="flat" cmpd="sng" algn="ctr">
                       <a:solidFill>
                         <a:srgbClr val="BFBFBF"/>
@@ -11567,7 +11579,7 @@
                         <a:buNone/>
                       </a:pPr>
                       <a:r>
-                        <a:rPr lang="en-US" sz="1050" dirty="0">
+                        <a:rPr lang="en-US" sz="1000" dirty="0">
                           <a:solidFill>
                             <a:srgbClr val="1F1F1F"/>
                           </a:solidFill>
@@ -11577,14 +11589,14 @@
                         </a:rPr>
                         <a:t>0.696</a:t>
                       </a:r>
-                      <a:endParaRPr lang="en-US" sz="1050" dirty="0">
+                      <a:endParaRPr lang="en-US" sz="1000" dirty="0">
                         <a:latin typeface="Calibri" charset="0"/>
                         <a:ea typeface="Calibri" charset="0"/>
                         <a:cs typeface="Calibri" charset="0"/>
                       </a:endParaRPr>
                     </a:p>
                   </a:txBody>
-                  <a:tcPr marL="36576" marR="36576" marT="36576" marB="36576" anchor="ctr">
+                  <a:tcPr marL="27432" marR="27432" marT="27432" marB="27432" anchor="ctr">
                     <a:lnL w="6350" cap="flat" cmpd="sng" algn="ctr">
                       <a:solidFill>
                         <a:srgbClr val="BFBFBF"/>
@@ -11632,7 +11644,7 @@
                         <a:buNone/>
                       </a:pPr>
                       <a:r>
-                        <a:rPr lang="en-US" sz="1050" dirty="0">
+                        <a:rPr lang="en-US" sz="1000" dirty="0">
                           <a:solidFill>
                             <a:srgbClr val="1F1F1F"/>
                           </a:solidFill>
@@ -11642,14 +11654,14 @@
                         </a:rPr>
                         <a:t>0.880</a:t>
                       </a:r>
-                      <a:endParaRPr lang="en-US" sz="1050" dirty="0">
+                      <a:endParaRPr lang="en-US" sz="1000" dirty="0">
                         <a:latin typeface="Calibri" charset="0"/>
                         <a:ea typeface="Calibri" charset="0"/>
                         <a:cs typeface="Calibri" charset="0"/>
                       </a:endParaRPr>
                     </a:p>
                   </a:txBody>
-                  <a:tcPr marL="36576" marR="36576" marT="36576" marB="36576" anchor="ctr">
+                  <a:tcPr marL="27432" marR="27432" marT="27432" marB="27432" anchor="ctr">
                     <a:lnL w="6350" cap="flat" cmpd="sng" algn="ctr">
                       <a:solidFill>
                         <a:srgbClr val="BFBFBF"/>
@@ -11697,7 +11709,7 @@
                         <a:buNone/>
                       </a:pPr>
                       <a:r>
-                        <a:rPr lang="en-US" sz="1050" dirty="0">
+                        <a:rPr lang="en-US" sz="1000" dirty="0">
                           <a:solidFill>
                             <a:srgbClr val="1F1F1F"/>
                           </a:solidFill>
@@ -11707,14 +11719,14 @@
                         </a:rPr>
                         <a:t>0.807</a:t>
                       </a:r>
-                      <a:endParaRPr lang="en-US" sz="1050" dirty="0">
+                      <a:endParaRPr lang="en-US" sz="1000" dirty="0">
                         <a:latin typeface="Calibri" charset="0"/>
                         <a:ea typeface="Calibri" charset="0"/>
                         <a:cs typeface="Calibri" charset="0"/>
                       </a:endParaRPr>
                     </a:p>
                   </a:txBody>
-                  <a:tcPr marL="36576" marR="36576" marT="36576" marB="36576" anchor="ctr">
+                  <a:tcPr marL="27432" marR="27432" marT="27432" marB="27432" anchor="ctr">
                     <a:lnL w="6350" cap="flat" cmpd="sng" algn="ctr">
                       <a:solidFill>
                         <a:srgbClr val="BFBFBF"/>
@@ -11762,7 +11774,7 @@
                         <a:buNone/>
                       </a:pPr>
                       <a:r>
-                        <a:rPr lang="en-US" sz="1050" dirty="0">
+                        <a:rPr lang="en-US" sz="1000" dirty="0">
                           <a:solidFill>
                             <a:srgbClr val="1F1F1F"/>
                           </a:solidFill>
@@ -11772,14 +11784,14 @@
                         </a:rPr>
                         <a:t>1.000</a:t>
                       </a:r>
-                      <a:endParaRPr lang="en-US" sz="1050" dirty="0">
+                      <a:endParaRPr lang="en-US" sz="1000" dirty="0">
                         <a:latin typeface="Calibri" charset="0"/>
                         <a:ea typeface="Calibri" charset="0"/>
                         <a:cs typeface="Calibri" charset="0"/>
                       </a:endParaRPr>
                     </a:p>
                   </a:txBody>
-                  <a:tcPr marL="36576" marR="36576" marT="36576" marB="36576" anchor="ctr">
+                  <a:tcPr marL="27432" marR="27432" marT="27432" marB="27432" anchor="ctr">
                     <a:lnL w="6350" cap="flat" cmpd="sng" algn="ctr">
                       <a:solidFill>
                         <a:srgbClr val="BFBFBF"/>
@@ -11819,7 +11831,7 @@
                   </a:tcPr>
                 </a:tc>
               </a:tr>
-              <a:tr h="301752">
+              <a:tr h="274320">
                 <a:tc>
                   <a:txBody>
                     <a:bodyPr/>
@@ -11829,7 +11841,7 @@
                         <a:buNone/>
                       </a:pPr>
                       <a:r>
-                        <a:rPr lang="en-US" sz="1050" dirty="0">
+                        <a:rPr lang="en-US" sz="1000" dirty="0">
                           <a:solidFill>
                             <a:srgbClr val="1F1F1F"/>
                           </a:solidFill>
@@ -11839,14 +11851,14 @@
                         </a:rPr>
                         <a:t>Decision Tree (class weights)</a:t>
                       </a:r>
-                      <a:endParaRPr lang="en-US" sz="1050" dirty="0">
+                      <a:endParaRPr lang="en-US" sz="1000" dirty="0">
                         <a:latin typeface="Calibri" charset="0"/>
                         <a:ea typeface="Calibri" charset="0"/>
                         <a:cs typeface="Calibri" charset="0"/>
                       </a:endParaRPr>
                     </a:p>
                   </a:txBody>
-                  <a:tcPr marL="36576" marR="36576" marT="36576" marB="36576" anchor="ctr">
+                  <a:tcPr marL="27432" marR="27432" marT="27432" marB="27432" anchor="ctr">
                     <a:lnL w="6350" cap="flat" cmpd="sng" algn="ctr">
                       <a:solidFill>
                         <a:srgbClr val="BFBFBF"/>
@@ -11894,7 +11906,7 @@
                         <a:buNone/>
                       </a:pPr>
                       <a:r>
-                        <a:rPr lang="en-US" sz="1050" dirty="0">
+                        <a:rPr lang="en-US" sz="1000" dirty="0">
                           <a:solidFill>
                             <a:srgbClr val="1F1F1F"/>
                           </a:solidFill>
@@ -11904,14 +11916,14 @@
                         </a:rPr>
                         <a:t>0.616</a:t>
                       </a:r>
-                      <a:endParaRPr lang="en-US" sz="1050" dirty="0">
+                      <a:endParaRPr lang="en-US" sz="1000" dirty="0">
                         <a:latin typeface="Calibri" charset="0"/>
                         <a:ea typeface="Calibri" charset="0"/>
                         <a:cs typeface="Calibri" charset="0"/>
                       </a:endParaRPr>
                     </a:p>
                   </a:txBody>
-                  <a:tcPr marL="36576" marR="36576" marT="36576" marB="36576" anchor="ctr">
+                  <a:tcPr marL="27432" marR="27432" marT="27432" marB="27432" anchor="ctr">
                     <a:lnL w="6350" cap="flat" cmpd="sng" algn="ctr">
                       <a:solidFill>
                         <a:srgbClr val="BFBFBF"/>
@@ -11959,7 +11971,7 @@
                         <a:buNone/>
                       </a:pPr>
                       <a:r>
-                        <a:rPr lang="en-US" sz="1050" dirty="0">
+                        <a:rPr lang="en-US" sz="1000" dirty="0">
                           <a:solidFill>
                             <a:srgbClr val="1F1F1F"/>
                           </a:solidFill>
@@ -11969,14 +11981,14 @@
                         </a:rPr>
                         <a:t>0.728</a:t>
                       </a:r>
-                      <a:endParaRPr lang="en-US" sz="1050" dirty="0">
+                      <a:endParaRPr lang="en-US" sz="1000" dirty="0">
                         <a:latin typeface="Calibri" charset="0"/>
                         <a:ea typeface="Calibri" charset="0"/>
                         <a:cs typeface="Calibri" charset="0"/>
                       </a:endParaRPr>
                     </a:p>
                   </a:txBody>
-                  <a:tcPr marL="36576" marR="36576" marT="36576" marB="36576" anchor="ctr">
+                  <a:tcPr marL="27432" marR="27432" marT="27432" marB="27432" anchor="ctr">
                     <a:lnL w="6350" cap="flat" cmpd="sng" algn="ctr">
                       <a:solidFill>
                         <a:srgbClr val="BFBFBF"/>
@@ -12024,7 +12036,7 @@
                         <a:buNone/>
                       </a:pPr>
                       <a:r>
-                        <a:rPr lang="en-US" sz="1050" dirty="0">
+                        <a:rPr lang="en-US" sz="1000" dirty="0">
                           <a:solidFill>
                             <a:srgbClr val="1F1F1F"/>
                           </a:solidFill>
@@ -12034,14 +12046,14 @@
                         </a:rPr>
                         <a:t>0.668</a:t>
                       </a:r>
-                      <a:endParaRPr lang="en-US" sz="1050" dirty="0">
+                      <a:endParaRPr lang="en-US" sz="1000" dirty="0">
                         <a:latin typeface="Calibri" charset="0"/>
                         <a:ea typeface="Calibri" charset="0"/>
                         <a:cs typeface="Calibri" charset="0"/>
                       </a:endParaRPr>
                     </a:p>
                   </a:txBody>
-                  <a:tcPr marL="36576" marR="36576" marT="36576" marB="36576" anchor="ctr">
+                  <a:tcPr marL="27432" marR="27432" marT="27432" marB="27432" anchor="ctr">
                     <a:lnL w="6350" cap="flat" cmpd="sng" algn="ctr">
                       <a:solidFill>
                         <a:srgbClr val="BFBFBF"/>
@@ -12089,7 +12101,7 @@
                         <a:buNone/>
                       </a:pPr>
                       <a:r>
-                        <a:rPr lang="en-US" sz="1050" dirty="0">
+                        <a:rPr lang="en-US" sz="1000" dirty="0">
                           <a:solidFill>
                             <a:srgbClr val="1F1F1F"/>
                           </a:solidFill>
@@ -12099,14 +12111,14 @@
                         </a:rPr>
                         <a:t>0.878</a:t>
                       </a:r>
-                      <a:endParaRPr lang="en-US" sz="1050" dirty="0">
+                      <a:endParaRPr lang="en-US" sz="1000" dirty="0">
                         <a:latin typeface="Calibri" charset="0"/>
                         <a:ea typeface="Calibri" charset="0"/>
                         <a:cs typeface="Calibri" charset="0"/>
                       </a:endParaRPr>
                     </a:p>
                   </a:txBody>
-                  <a:tcPr marL="36576" marR="36576" marT="36576" marB="36576" anchor="ctr">
+                  <a:tcPr marL="27432" marR="27432" marT="27432" marB="27432" anchor="ctr">
                     <a:lnL w="6350" cap="flat" cmpd="sng" algn="ctr">
                       <a:solidFill>
                         <a:srgbClr val="BFBFBF"/>
@@ -12154,7 +12166,7 @@
                         <a:buNone/>
                       </a:pPr>
                       <a:r>
-                        <a:rPr lang="en-US" sz="1050" dirty="0">
+                        <a:rPr lang="en-US" sz="1000" dirty="0">
                           <a:solidFill>
                             <a:srgbClr val="1F1F1F"/>
                           </a:solidFill>
@@ -12164,14 +12176,14 @@
                         </a:rPr>
                         <a:t>0.779</a:t>
                       </a:r>
-                      <a:endParaRPr lang="en-US" sz="1050" dirty="0">
+                      <a:endParaRPr lang="en-US" sz="1000" dirty="0">
                         <a:latin typeface="Calibri" charset="0"/>
                         <a:ea typeface="Calibri" charset="0"/>
                         <a:cs typeface="Calibri" charset="0"/>
                       </a:endParaRPr>
                     </a:p>
                   </a:txBody>
-                  <a:tcPr marL="36576" marR="36576" marT="36576" marB="36576" anchor="ctr">
+                  <a:tcPr marL="27432" marR="27432" marT="27432" marB="27432" anchor="ctr">
                     <a:lnL w="6350" cap="flat" cmpd="sng" algn="ctr">
                       <a:solidFill>
                         <a:srgbClr val="BFBFBF"/>
@@ -12219,7 +12231,7 @@
                         <a:buNone/>
                       </a:pPr>
                       <a:r>
-                        <a:rPr lang="en-US" sz="1050" dirty="0">
+                        <a:rPr lang="en-US" sz="1000" dirty="0">
                           <a:solidFill>
                             <a:srgbClr val="1F1F1F"/>
                           </a:solidFill>
@@ -12229,14 +12241,14 @@
                         </a:rPr>
                         <a:t>1.000</a:t>
                       </a:r>
-                      <a:endParaRPr lang="en-US" sz="1050" dirty="0">
+                      <a:endParaRPr lang="en-US" sz="1000" dirty="0">
                         <a:latin typeface="Calibri" charset="0"/>
                         <a:ea typeface="Calibri" charset="0"/>
                         <a:cs typeface="Calibri" charset="0"/>
                       </a:endParaRPr>
                     </a:p>
                   </a:txBody>
-                  <a:tcPr marL="36576" marR="36576" marT="36576" marB="36576" anchor="ctr">
+                  <a:tcPr marL="27432" marR="27432" marT="27432" marB="27432" anchor="ctr">
                     <a:lnL w="6350" cap="flat" cmpd="sng" algn="ctr">
                       <a:solidFill>
                         <a:srgbClr val="BFBFBF"/>
@@ -12276,7 +12288,7 @@
                   </a:tcPr>
                 </a:tc>
               </a:tr>
-              <a:tr h="301752">
+              <a:tr h="274320">
                 <a:tc>
                   <a:txBody>
                     <a:bodyPr/>
@@ -12286,7 +12298,7 @@
                         <a:buNone/>
                       </a:pPr>
                       <a:r>
-                        <a:rPr lang="en-US" sz="1050" dirty="0">
+                        <a:rPr lang="en-US" sz="1000" dirty="0">
                           <a:solidFill>
                             <a:srgbClr val="1F1F1F"/>
                           </a:solidFill>
@@ -12296,14 +12308,14 @@
                         </a:rPr>
                         <a:t>Decision Tree (tuned: balanced, min 20 per leaf)</a:t>
                       </a:r>
-                      <a:endParaRPr lang="en-US" sz="1050" dirty="0">
+                      <a:endParaRPr lang="en-US" sz="1000" dirty="0">
                         <a:latin typeface="Calibri" charset="0"/>
                         <a:ea typeface="Calibri" charset="0"/>
                         <a:cs typeface="Calibri" charset="0"/>
                       </a:endParaRPr>
                     </a:p>
                   </a:txBody>
-                  <a:tcPr marL="36576" marR="36576" marT="36576" marB="36576" anchor="ctr">
+                  <a:tcPr marL="27432" marR="27432" marT="27432" marB="27432" anchor="ctr">
                     <a:lnL w="6350" cap="flat" cmpd="sng" algn="ctr">
                       <a:solidFill>
                         <a:srgbClr val="BFBFBF"/>
@@ -12351,7 +12363,7 @@
                         <a:buNone/>
                       </a:pPr>
                       <a:r>
-                        <a:rPr lang="en-US" sz="1050" dirty="0">
+                        <a:rPr lang="en-US" sz="1000" dirty="0">
                           <a:solidFill>
                             <a:srgbClr val="1F1F1F"/>
                           </a:solidFill>
@@ -12361,14 +12373,14 @@
                         </a:rPr>
                         <a:t>0.818</a:t>
                       </a:r>
-                      <a:endParaRPr lang="en-US" sz="1050" dirty="0">
+                      <a:endParaRPr lang="en-US" sz="1000" dirty="0">
                         <a:latin typeface="Calibri" charset="0"/>
                         <a:ea typeface="Calibri" charset="0"/>
                         <a:cs typeface="Calibri" charset="0"/>
                       </a:endParaRPr>
                     </a:p>
                   </a:txBody>
-                  <a:tcPr marL="36576" marR="36576" marT="36576" marB="36576" anchor="ctr">
+                  <a:tcPr marL="27432" marR="27432" marT="27432" marB="27432" anchor="ctr">
                     <a:lnL w="6350" cap="flat" cmpd="sng" algn="ctr">
                       <a:solidFill>
                         <a:srgbClr val="BFBFBF"/>
@@ -12416,7 +12428,7 @@
                         <a:buNone/>
                       </a:pPr>
                       <a:r>
-                        <a:rPr lang="en-US" sz="1050" dirty="0">
+                        <a:rPr lang="en-US" sz="1000" dirty="0">
                           <a:solidFill>
                             <a:srgbClr val="1F1F1F"/>
                           </a:solidFill>
@@ -12426,14 +12438,14 @@
                         </a:rPr>
                         <a:t>0.533</a:t>
                       </a:r>
-                      <a:endParaRPr lang="en-US" sz="1050" dirty="0">
+                      <a:endParaRPr lang="en-US" sz="1000" dirty="0">
                         <a:latin typeface="Calibri" charset="0"/>
                         <a:ea typeface="Calibri" charset="0"/>
                         <a:cs typeface="Calibri" charset="0"/>
                       </a:endParaRPr>
                     </a:p>
                   </a:txBody>
-                  <a:tcPr marL="36576" marR="36576" marT="36576" marB="36576" anchor="ctr">
+                  <a:tcPr marL="27432" marR="27432" marT="27432" marB="27432" anchor="ctr">
                     <a:lnL w="6350" cap="flat" cmpd="sng" algn="ctr">
                       <a:solidFill>
                         <a:srgbClr val="BFBFBF"/>
@@ -12481,7 +12493,7 @@
                         <a:buNone/>
                       </a:pPr>
                       <a:r>
-                        <a:rPr lang="en-US" sz="1050" dirty="0">
+                        <a:rPr lang="en-US" sz="1000" dirty="0">
                           <a:solidFill>
                             <a:srgbClr val="1F1F1F"/>
                           </a:solidFill>
@@ -12491,14 +12503,14 @@
                         </a:rPr>
                         <a:t>0.645</a:t>
                       </a:r>
-                      <a:endParaRPr lang="en-US" sz="1050" dirty="0">
+                      <a:endParaRPr lang="en-US" sz="1000" dirty="0">
                         <a:latin typeface="Calibri" charset="0"/>
                         <a:ea typeface="Calibri" charset="0"/>
                         <a:cs typeface="Calibri" charset="0"/>
                       </a:endParaRPr>
                     </a:p>
                   </a:txBody>
-                  <a:tcPr marL="36576" marR="36576" marT="36576" marB="36576" anchor="ctr">
+                  <a:tcPr marL="27432" marR="27432" marT="27432" marB="27432" anchor="ctr">
                     <a:lnL w="6350" cap="flat" cmpd="sng" algn="ctr">
                       <a:solidFill>
                         <a:srgbClr val="BFBFBF"/>
@@ -12546,7 +12558,7 @@
                         <a:buNone/>
                       </a:pPr>
                       <a:r>
-                        <a:rPr lang="en-US" sz="1050" dirty="0">
+                        <a:rPr lang="en-US" sz="1000" dirty="0">
                           <a:solidFill>
                             <a:srgbClr val="1F1F1F"/>
                           </a:solidFill>
@@ -12556,14 +12568,14 @@
                         </a:rPr>
                         <a:t>0.820</a:t>
                       </a:r>
-                      <a:endParaRPr lang="en-US" sz="1050" dirty="0">
+                      <a:endParaRPr lang="en-US" sz="1000" dirty="0">
                         <a:latin typeface="Calibri" charset="0"/>
                         <a:ea typeface="Calibri" charset="0"/>
                         <a:cs typeface="Calibri" charset="0"/>
                       </a:endParaRPr>
                     </a:p>
                   </a:txBody>
-                  <a:tcPr marL="36576" marR="36576" marT="36576" marB="36576" anchor="ctr">
+                  <a:tcPr marL="27432" marR="27432" marT="27432" marB="27432" anchor="ctr">
                     <a:lnL w="6350" cap="flat" cmpd="sng" algn="ctr">
                       <a:solidFill>
                         <a:srgbClr val="BFBFBF"/>
@@ -12611,7 +12623,7 @@
                         <a:buNone/>
                       </a:pPr>
                       <a:r>
-                        <a:rPr lang="en-US" sz="1050" dirty="0">
+                        <a:rPr lang="en-US" sz="1000" dirty="0">
                           <a:solidFill>
                             <a:srgbClr val="1F1F1F"/>
                           </a:solidFill>
@@ -12621,14 +12633,14 @@
                         </a:rPr>
                         <a:t>0.879</a:t>
                       </a:r>
-                      <a:endParaRPr lang="en-US" sz="1050" dirty="0">
+                      <a:endParaRPr lang="en-US" sz="1000" dirty="0">
                         <a:latin typeface="Calibri" charset="0"/>
                         <a:ea typeface="Calibri" charset="0"/>
                         <a:cs typeface="Calibri" charset="0"/>
                       </a:endParaRPr>
                     </a:p>
                   </a:txBody>
-                  <a:tcPr marL="36576" marR="36576" marT="36576" marB="36576" anchor="ctr">
+                  <a:tcPr marL="27432" marR="27432" marT="27432" marB="27432" anchor="ctr">
                     <a:lnL w="6350" cap="flat" cmpd="sng" algn="ctr">
                       <a:solidFill>
                         <a:srgbClr val="BFBFBF"/>
@@ -12676,7 +12688,7 @@
                         <a:buNone/>
                       </a:pPr>
                       <a:r>
-                        <a:rPr lang="en-US" sz="1050" dirty="0">
+                        <a:rPr lang="en-US" sz="1000" dirty="0">
                           <a:solidFill>
                             <a:srgbClr val="1F1F1F"/>
                           </a:solidFill>
@@ -12686,14 +12698,14 @@
                         </a:rPr>
                         <a:t>0.924</a:t>
                       </a:r>
-                      <a:endParaRPr lang="en-US" sz="1050" dirty="0">
+                      <a:endParaRPr lang="en-US" sz="1000" dirty="0">
                         <a:latin typeface="Calibri" charset="0"/>
                         <a:ea typeface="Calibri" charset="0"/>
                         <a:cs typeface="Calibri" charset="0"/>
                       </a:endParaRPr>
                     </a:p>
                   </a:txBody>
-                  <a:tcPr marL="36576" marR="36576" marT="36576" marB="36576" anchor="ctr">
+                  <a:tcPr marL="27432" marR="27432" marT="27432" marB="27432" anchor="ctr">
                     <a:lnL w="6350" cap="flat" cmpd="sng" algn="ctr">
                       <a:solidFill>
                         <a:srgbClr val="BFBFBF"/>
@@ -12733,7 +12745,7 @@
                   </a:tcPr>
                 </a:tc>
               </a:tr>
-              <a:tr h="301752">
+              <a:tr h="274320">
                 <a:tc>
                   <a:txBody>
                     <a:bodyPr/>
@@ -12743,7 +12755,7 @@
                         <a:buNone/>
                       </a:pPr>
                       <a:r>
-                        <a:rPr lang="en-US" sz="1050" dirty="0">
+                        <a:rPr lang="en-US" sz="1000" dirty="0">
                           <a:solidFill>
                             <a:srgbClr val="1F1F1F"/>
                           </a:solidFill>
@@ -12751,16 +12763,16 @@
                           <a:ea typeface="Calibri" pitchFamily="34" charset="-122"/>
                           <a:cs typeface="Calibri" pitchFamily="34" charset="-120"/>
                         </a:rPr>
-                        <a:t>Random Forest (default, 200 trees)</a:t>
+                        <a:t>Bagging (200 fully grown trees)</a:t>
                       </a:r>
-                      <a:endParaRPr lang="en-US" sz="1050" dirty="0">
+                      <a:endParaRPr lang="en-US" sz="1000" dirty="0">
                         <a:latin typeface="Calibri" charset="0"/>
                         <a:ea typeface="Calibri" charset="0"/>
                         <a:cs typeface="Calibri" charset="0"/>
                       </a:endParaRPr>
                     </a:p>
                   </a:txBody>
-                  <a:tcPr marL="36576" marR="36576" marT="36576" marB="36576" anchor="ctr">
+                  <a:tcPr marL="27432" marR="27432" marT="27432" marB="27432" anchor="ctr">
                     <a:lnL w="6350" cap="flat" cmpd="sng" algn="ctr">
                       <a:solidFill>
                         <a:srgbClr val="BFBFBF"/>
@@ -12808,7 +12820,7 @@
                         <a:buNone/>
                       </a:pPr>
                       <a:r>
-                        <a:rPr lang="en-US" sz="1050" dirty="0">
+                        <a:rPr lang="en-US" sz="1000" dirty="0">
                           <a:solidFill>
                             <a:srgbClr val="1F1F1F"/>
                           </a:solidFill>
@@ -12816,16 +12828,16 @@
                           <a:ea typeface="Calibri" pitchFamily="34" charset="-122"/>
                           <a:cs typeface="Calibri" pitchFamily="34" charset="-120"/>
                         </a:rPr>
-                        <a:t>0.689</a:t>
+                        <a:t>0.678</a:t>
                       </a:r>
-                      <a:endParaRPr lang="en-US" sz="1050" dirty="0">
+                      <a:endParaRPr lang="en-US" sz="1000" dirty="0">
                         <a:latin typeface="Calibri" charset="0"/>
                         <a:ea typeface="Calibri" charset="0"/>
                         <a:cs typeface="Calibri" charset="0"/>
                       </a:endParaRPr>
                     </a:p>
                   </a:txBody>
-                  <a:tcPr marL="36576" marR="36576" marT="36576" marB="36576" anchor="ctr">
+                  <a:tcPr marL="27432" marR="27432" marT="27432" marB="27432" anchor="ctr">
                     <a:lnL w="6350" cap="flat" cmpd="sng" algn="ctr">
                       <a:solidFill>
                         <a:srgbClr val="BFBFBF"/>
@@ -12873,7 +12885,7 @@
                         <a:buNone/>
                       </a:pPr>
                       <a:r>
-                        <a:rPr lang="en-US" sz="1050" dirty="0">
+                        <a:rPr lang="en-US" sz="1000" dirty="0">
                           <a:solidFill>
                             <a:srgbClr val="1F1F1F"/>
                           </a:solidFill>
@@ -12881,16 +12893,16 @@
                           <a:ea typeface="Calibri" pitchFamily="34" charset="-122"/>
                           <a:cs typeface="Calibri" pitchFamily="34" charset="-120"/>
                         </a:rPr>
-                        <a:t>0.845</a:t>
+                        <a:t>0.826</a:t>
                       </a:r>
-                      <a:endParaRPr lang="en-US" sz="1050" dirty="0">
+                      <a:endParaRPr lang="en-US" sz="1000" dirty="0">
                         <a:latin typeface="Calibri" charset="0"/>
                         <a:ea typeface="Calibri" charset="0"/>
                         <a:cs typeface="Calibri" charset="0"/>
                       </a:endParaRPr>
                     </a:p>
                   </a:txBody>
-                  <a:tcPr marL="36576" marR="36576" marT="36576" marB="36576" anchor="ctr">
+                  <a:tcPr marL="27432" marR="27432" marT="27432" marB="27432" anchor="ctr">
                     <a:lnL w="6350" cap="flat" cmpd="sng" algn="ctr">
                       <a:solidFill>
                         <a:srgbClr val="BFBFBF"/>
@@ -12938,7 +12950,7 @@
                         <a:buNone/>
                       </a:pPr>
                       <a:r>
-                        <a:rPr lang="en-US" sz="1050" dirty="0">
+                        <a:rPr lang="en-US" sz="1000" dirty="0">
                           <a:solidFill>
                             <a:srgbClr val="1F1F1F"/>
                           </a:solidFill>
@@ -12946,16 +12958,16 @@
                           <a:ea typeface="Calibri" pitchFamily="34" charset="-122"/>
                           <a:cs typeface="Calibri" pitchFamily="34" charset="-120"/>
                         </a:rPr>
-                        <a:t>0.759</a:t>
+                        <a:t>0.745</a:t>
                       </a:r>
-                      <a:endParaRPr lang="en-US" sz="1050" dirty="0">
+                      <a:endParaRPr lang="en-US" sz="1000" dirty="0">
                         <a:latin typeface="Calibri" charset="0"/>
                         <a:ea typeface="Calibri" charset="0"/>
                         <a:cs typeface="Calibri" charset="0"/>
                       </a:endParaRPr>
                     </a:p>
                   </a:txBody>
-                  <a:tcPr marL="36576" marR="36576" marT="36576" marB="36576" anchor="ctr">
+                  <a:tcPr marL="27432" marR="27432" marT="27432" marB="27432" anchor="ctr">
                     <a:lnL w="6350" cap="flat" cmpd="sng" algn="ctr">
                       <a:solidFill>
                         <a:srgbClr val="BFBFBF"/>
@@ -13003,7 +13015,7 @@
                         <a:buNone/>
                       </a:pPr>
                       <a:r>
-                        <a:rPr lang="en-US" sz="1050" dirty="0">
+                        <a:rPr lang="en-US" sz="1000" dirty="0">
                           <a:solidFill>
                             <a:srgbClr val="1F1F1F"/>
                           </a:solidFill>
@@ -13011,16 +13023,16 @@
                           <a:ea typeface="Calibri" pitchFamily="34" charset="-122"/>
                           <a:cs typeface="Calibri" pitchFamily="34" charset="-120"/>
                         </a:rPr>
-                        <a:t>0.913</a:t>
+                        <a:t>0.907</a:t>
                       </a:r>
-                      <a:endParaRPr lang="en-US" sz="1050" dirty="0">
+                      <a:endParaRPr lang="en-US" sz="1000" dirty="0">
                         <a:latin typeface="Calibri" charset="0"/>
                         <a:ea typeface="Calibri" charset="0"/>
                         <a:cs typeface="Calibri" charset="0"/>
                       </a:endParaRPr>
                     </a:p>
                   </a:txBody>
-                  <a:tcPr marL="36576" marR="36576" marT="36576" marB="36576" anchor="ctr">
+                  <a:tcPr marL="27432" marR="27432" marT="27432" marB="27432" anchor="ctr">
                     <a:lnL w="6350" cap="flat" cmpd="sng" algn="ctr">
                       <a:solidFill>
                         <a:srgbClr val="BFBFBF"/>
@@ -13068,7 +13080,7 @@
                         <a:buNone/>
                       </a:pPr>
                       <a:r>
-                        <a:rPr lang="en-US" sz="1050" dirty="0">
+                        <a:rPr lang="en-US" sz="1000" dirty="0">
                           <a:solidFill>
                             <a:srgbClr val="1F1F1F"/>
                           </a:solidFill>
@@ -13076,16 +13088,16 @@
                           <a:ea typeface="Calibri" pitchFamily="34" charset="-122"/>
                           <a:cs typeface="Calibri" pitchFamily="34" charset="-120"/>
                         </a:rPr>
-                        <a:t>0.962</a:t>
+                        <a:t>0.946</a:t>
                       </a:r>
-                      <a:endParaRPr lang="en-US" sz="1050" dirty="0">
+                      <a:endParaRPr lang="en-US" sz="1000" dirty="0">
                         <a:latin typeface="Calibri" charset="0"/>
                         <a:ea typeface="Calibri" charset="0"/>
                         <a:cs typeface="Calibri" charset="0"/>
                       </a:endParaRPr>
                     </a:p>
                   </a:txBody>
-                  <a:tcPr marL="36576" marR="36576" marT="36576" marB="36576" anchor="ctr">
+                  <a:tcPr marL="27432" marR="27432" marT="27432" marB="27432" anchor="ctr">
                     <a:lnL w="6350" cap="flat" cmpd="sng" algn="ctr">
                       <a:solidFill>
                         <a:srgbClr val="BFBFBF"/>
@@ -13133,7 +13145,7 @@
                         <a:buNone/>
                       </a:pPr>
                       <a:r>
-                        <a:rPr lang="en-US" sz="1050" dirty="0">
+                        <a:rPr lang="en-US" sz="1000" dirty="0">
                           <a:solidFill>
                             <a:srgbClr val="1F1F1F"/>
                           </a:solidFill>
@@ -13143,14 +13155,14 @@
                         </a:rPr>
                         <a:t>1.000</a:t>
                       </a:r>
-                      <a:endParaRPr lang="en-US" sz="1050" dirty="0">
+                      <a:endParaRPr lang="en-US" sz="1000" dirty="0">
                         <a:latin typeface="Calibri" charset="0"/>
                         <a:ea typeface="Calibri" charset="0"/>
                         <a:cs typeface="Calibri" charset="0"/>
                       </a:endParaRPr>
                     </a:p>
                   </a:txBody>
-                  <a:tcPr marL="36576" marR="36576" marT="36576" marB="36576" anchor="ctr">
+                  <a:tcPr marL="27432" marR="27432" marT="27432" marB="27432" anchor="ctr">
                     <a:lnL w="6350" cap="flat" cmpd="sng" algn="ctr">
                       <a:solidFill>
                         <a:srgbClr val="BFBFBF"/>
@@ -13190,7 +13202,7 @@
                   </a:tcPr>
                 </a:tc>
               </a:tr>
-              <a:tr h="301752">
+              <a:tr h="274320">
                 <a:tc>
                   <a:txBody>
                     <a:bodyPr/>
@@ -13200,7 +13212,7 @@
                         <a:buNone/>
                       </a:pPr>
                       <a:r>
-                        <a:rPr lang="en-US" sz="1050" dirty="0">
+                        <a:rPr lang="en-US" sz="1000" dirty="0">
                           <a:solidFill>
                             <a:srgbClr val="1F1F1F"/>
                           </a:solidFill>
@@ -13208,16 +13220,16 @@
                           <a:ea typeface="Calibri" pitchFamily="34" charset="-122"/>
                           <a:cs typeface="Calibri" pitchFamily="34" charset="-120"/>
                         </a:rPr>
-                        <a:t>Random Forest (class weights 0.2/0.8)</a:t>
+                        <a:t>Random Forest (default, 200 trees)</a:t>
                       </a:r>
-                      <a:endParaRPr lang="en-US" sz="1050" dirty="0">
+                      <a:endParaRPr lang="en-US" sz="1000" dirty="0">
                         <a:latin typeface="Calibri" charset="0"/>
                         <a:ea typeface="Calibri" charset="0"/>
                         <a:cs typeface="Calibri" charset="0"/>
                       </a:endParaRPr>
                     </a:p>
                   </a:txBody>
-                  <a:tcPr marL="36576" marR="36576" marT="36576" marB="36576" anchor="ctr">
+                  <a:tcPr marL="27432" marR="27432" marT="27432" marB="27432" anchor="ctr">
                     <a:lnL w="6350" cap="flat" cmpd="sng" algn="ctr">
                       <a:solidFill>
                         <a:srgbClr val="BFBFBF"/>
@@ -13265,7 +13277,7 @@
                         <a:buNone/>
                       </a:pPr>
                       <a:r>
-                        <a:rPr lang="en-US" sz="1050" dirty="0">
+                        <a:rPr lang="en-US" sz="1000" dirty="0">
                           <a:solidFill>
                             <a:srgbClr val="1F1F1F"/>
                           </a:solidFill>
@@ -13273,16 +13285,16 @@
                           <a:ea typeface="Calibri" pitchFamily="34" charset="-122"/>
                           <a:cs typeface="Calibri" pitchFamily="34" charset="-120"/>
                         </a:rPr>
-                        <a:t>0.784</a:t>
+                        <a:t>0.689</a:t>
                       </a:r>
-                      <a:endParaRPr lang="en-US" sz="1050" dirty="0">
+                      <a:endParaRPr lang="en-US" sz="1000" dirty="0">
                         <a:latin typeface="Calibri" charset="0"/>
                         <a:ea typeface="Calibri" charset="0"/>
                         <a:cs typeface="Calibri" charset="0"/>
                       </a:endParaRPr>
                     </a:p>
                   </a:txBody>
-                  <a:tcPr marL="36576" marR="36576" marT="36576" marB="36576" anchor="ctr">
+                  <a:tcPr marL="27432" marR="27432" marT="27432" marB="27432" anchor="ctr">
                     <a:lnL w="6350" cap="flat" cmpd="sng" algn="ctr">
                       <a:solidFill>
                         <a:srgbClr val="BFBFBF"/>
@@ -13330,7 +13342,7 @@
                         <a:buNone/>
                       </a:pPr>
                       <a:r>
-                        <a:rPr lang="en-US" sz="1050" dirty="0">
+                        <a:rPr lang="en-US" sz="1000" dirty="0">
                           <a:solidFill>
                             <a:srgbClr val="1F1F1F"/>
                           </a:solidFill>
@@ -13338,16 +13350,16 @@
                           <a:ea typeface="Calibri" pitchFamily="34" charset="-122"/>
                           <a:cs typeface="Calibri" pitchFamily="34" charset="-120"/>
                         </a:rPr>
-                        <a:t>0.773</a:t>
+                        <a:t>0.845</a:t>
                       </a:r>
-                      <a:endParaRPr lang="en-US" sz="1050" dirty="0">
+                      <a:endParaRPr lang="en-US" sz="1000" dirty="0">
                         <a:latin typeface="Calibri" charset="0"/>
                         <a:ea typeface="Calibri" charset="0"/>
                         <a:cs typeface="Calibri" charset="0"/>
                       </a:endParaRPr>
                     </a:p>
                   </a:txBody>
-                  <a:tcPr marL="36576" marR="36576" marT="36576" marB="36576" anchor="ctr">
+                  <a:tcPr marL="27432" marR="27432" marT="27432" marB="27432" anchor="ctr">
                     <a:lnL w="6350" cap="flat" cmpd="sng" algn="ctr">
                       <a:solidFill>
                         <a:srgbClr val="BFBFBF"/>
@@ -13395,7 +13407,7 @@
                         <a:buNone/>
                       </a:pPr>
                       <a:r>
-                        <a:rPr lang="en-US" sz="1050" dirty="0">
+                        <a:rPr lang="en-US" sz="1000" dirty="0">
                           <a:solidFill>
                             <a:srgbClr val="1F1F1F"/>
                           </a:solidFill>
@@ -13403,16 +13415,16 @@
                           <a:ea typeface="Calibri" pitchFamily="34" charset="-122"/>
                           <a:cs typeface="Calibri" pitchFamily="34" charset="-120"/>
                         </a:rPr>
-                        <a:t>0.779</a:t>
+                        <a:t>0.759</a:t>
                       </a:r>
-                      <a:endParaRPr lang="en-US" sz="1050" dirty="0">
+                      <a:endParaRPr lang="en-US" sz="1000" dirty="0">
                         <a:latin typeface="Calibri" charset="0"/>
                         <a:ea typeface="Calibri" charset="0"/>
                         <a:cs typeface="Calibri" charset="0"/>
                       </a:endParaRPr>
                     </a:p>
                   </a:txBody>
-                  <a:tcPr marL="36576" marR="36576" marT="36576" marB="36576" anchor="ctr">
+                  <a:tcPr marL="27432" marR="27432" marT="27432" marB="27432" anchor="ctr">
                     <a:lnL w="6350" cap="flat" cmpd="sng" algn="ctr">
                       <a:solidFill>
                         <a:srgbClr val="BFBFBF"/>
@@ -13460,7 +13472,7 @@
                         <a:buNone/>
                       </a:pPr>
                       <a:r>
-                        <a:rPr lang="en-US" sz="1050" dirty="0">
+                        <a:rPr lang="en-US" sz="1000" dirty="0">
                           <a:solidFill>
                             <a:srgbClr val="1F1F1F"/>
                           </a:solidFill>
@@ -13468,16 +13480,16 @@
                           <a:ea typeface="Calibri" pitchFamily="34" charset="-122"/>
                           <a:cs typeface="Calibri" pitchFamily="34" charset="-120"/>
                         </a:rPr>
-                        <a:t>0.911</a:t>
+                        <a:t>0.913</a:t>
                       </a:r>
-                      <a:endParaRPr lang="en-US" sz="1050" dirty="0">
+                      <a:endParaRPr lang="en-US" sz="1000" dirty="0">
                         <a:latin typeface="Calibri" charset="0"/>
                         <a:ea typeface="Calibri" charset="0"/>
                         <a:cs typeface="Calibri" charset="0"/>
                       </a:endParaRPr>
                     </a:p>
                   </a:txBody>
-                  <a:tcPr marL="36576" marR="36576" marT="36576" marB="36576" anchor="ctr">
+                  <a:tcPr marL="27432" marR="27432" marT="27432" marB="27432" anchor="ctr">
                     <a:lnL w="6350" cap="flat" cmpd="sng" algn="ctr">
                       <a:solidFill>
                         <a:srgbClr val="BFBFBF"/>
@@ -13525,7 +13537,7 @@
                         <a:buNone/>
                       </a:pPr>
                       <a:r>
-                        <a:rPr lang="en-US" sz="1050" dirty="0">
+                        <a:rPr lang="en-US" sz="1000" dirty="0">
                           <a:solidFill>
                             <a:srgbClr val="1F1F1F"/>
                           </a:solidFill>
@@ -13533,16 +13545,16 @@
                           <a:ea typeface="Calibri" pitchFamily="34" charset="-122"/>
                           <a:cs typeface="Calibri" pitchFamily="34" charset="-120"/>
                         </a:rPr>
-                        <a:t>0.958</a:t>
+                        <a:t>0.962</a:t>
                       </a:r>
-                      <a:endParaRPr lang="en-US" sz="1050" dirty="0">
+                      <a:endParaRPr lang="en-US" sz="1000" dirty="0">
                         <a:latin typeface="Calibri" charset="0"/>
                         <a:ea typeface="Calibri" charset="0"/>
                         <a:cs typeface="Calibri" charset="0"/>
                       </a:endParaRPr>
                     </a:p>
                   </a:txBody>
-                  <a:tcPr marL="36576" marR="36576" marT="36576" marB="36576" anchor="ctr">
+                  <a:tcPr marL="27432" marR="27432" marT="27432" marB="27432" anchor="ctr">
                     <a:lnL w="6350" cap="flat" cmpd="sng" algn="ctr">
                       <a:solidFill>
                         <a:srgbClr val="BFBFBF"/>
@@ -13590,7 +13602,7 @@
                         <a:buNone/>
                       </a:pPr>
                       <a:r>
-                        <a:rPr lang="en-US" sz="1050" dirty="0">
+                        <a:rPr lang="en-US" sz="1000" dirty="0">
                           <a:solidFill>
                             <a:srgbClr val="1F1F1F"/>
                           </a:solidFill>
@@ -13600,14 +13612,14 @@
                         </a:rPr>
                         <a:t>1.000</a:t>
                       </a:r>
-                      <a:endParaRPr lang="en-US" sz="1050" dirty="0">
+                      <a:endParaRPr lang="en-US" sz="1000" dirty="0">
                         <a:latin typeface="Calibri" charset="0"/>
                         <a:ea typeface="Calibri" charset="0"/>
                         <a:cs typeface="Calibri" charset="0"/>
                       </a:endParaRPr>
                     </a:p>
                   </a:txBody>
-                  <a:tcPr marL="36576" marR="36576" marT="36576" marB="36576" anchor="ctr">
+                  <a:tcPr marL="27432" marR="27432" marT="27432" marB="27432" anchor="ctr">
                     <a:lnL w="6350" cap="flat" cmpd="sng" algn="ctr">
                       <a:solidFill>
                         <a:srgbClr val="BFBFBF"/>
@@ -13647,7 +13659,7 @@
                   </a:tcPr>
                 </a:tc>
               </a:tr>
-              <a:tr h="301752">
+              <a:tr h="274320">
                 <a:tc>
                   <a:txBody>
                     <a:bodyPr/>
@@ -13657,7 +13669,7 @@
                         <a:buNone/>
                       </a:pPr>
                       <a:r>
-                        <a:rPr lang="en-US" sz="1050" dirty="0">
+                        <a:rPr lang="en-US" sz="1000" dirty="0">
                           <a:solidFill>
                             <a:srgbClr val="1F1F1F"/>
                           </a:solidFill>
@@ -13665,16 +13677,16 @@
                           <a:ea typeface="Calibri" pitchFamily="34" charset="-122"/>
                           <a:cs typeface="Calibri" pitchFamily="34" charset="-120"/>
                         </a:rPr>
-                        <a:t>Random Forest (tuned for recall)</a:t>
+                        <a:t>Random Forest (class weights 0.2/0.8)</a:t>
                       </a:r>
-                      <a:endParaRPr lang="en-US" sz="1050" dirty="0">
+                      <a:endParaRPr lang="en-US" sz="1000" dirty="0">
                         <a:latin typeface="Calibri" charset="0"/>
                         <a:ea typeface="Calibri" charset="0"/>
                         <a:cs typeface="Calibri" charset="0"/>
                       </a:endParaRPr>
                     </a:p>
                   </a:txBody>
-                  <a:tcPr marL="36576" marR="36576" marT="36576" marB="36576" anchor="ctr">
+                  <a:tcPr marL="27432" marR="27432" marT="27432" marB="27432" anchor="ctr">
                     <a:lnL w="6350" cap="flat" cmpd="sng" algn="ctr">
                       <a:solidFill>
                         <a:srgbClr val="BFBFBF"/>
@@ -13722,7 +13734,7 @@
                         <a:buNone/>
                       </a:pPr>
                       <a:r>
-                        <a:rPr lang="en-US" sz="1050" dirty="0">
+                        <a:rPr lang="en-US" sz="1000" dirty="0">
                           <a:solidFill>
                             <a:srgbClr val="1F1F1F"/>
                           </a:solidFill>
@@ -13732,14 +13744,14 @@
                         </a:rPr>
                         <a:t>0.784</a:t>
                       </a:r>
-                      <a:endParaRPr lang="en-US" sz="1050" dirty="0">
+                      <a:endParaRPr lang="en-US" sz="1000" dirty="0">
                         <a:latin typeface="Calibri" charset="0"/>
                         <a:ea typeface="Calibri" charset="0"/>
                         <a:cs typeface="Calibri" charset="0"/>
                       </a:endParaRPr>
                     </a:p>
                   </a:txBody>
-                  <a:tcPr marL="36576" marR="36576" marT="36576" marB="36576" anchor="ctr">
+                  <a:tcPr marL="27432" marR="27432" marT="27432" marB="27432" anchor="ctr">
                     <a:lnL w="6350" cap="flat" cmpd="sng" algn="ctr">
                       <a:solidFill>
                         <a:srgbClr val="BFBFBF"/>
@@ -13787,7 +13799,7 @@
                         <a:buNone/>
                       </a:pPr>
                       <a:r>
-                        <a:rPr lang="en-US" sz="1050" dirty="0">
+                        <a:rPr lang="en-US" sz="1000" dirty="0">
                           <a:solidFill>
                             <a:srgbClr val="1F1F1F"/>
                           </a:solidFill>
@@ -13795,16 +13807,16 @@
                           <a:ea typeface="Calibri" pitchFamily="34" charset="-122"/>
                           <a:cs typeface="Calibri" pitchFamily="34" charset="-120"/>
                         </a:rPr>
-                        <a:t>0.653</a:t>
+                        <a:t>0.773</a:t>
                       </a:r>
-                      <a:endParaRPr lang="en-US" sz="1050" dirty="0">
+                      <a:endParaRPr lang="en-US" sz="1000" dirty="0">
                         <a:latin typeface="Calibri" charset="0"/>
                         <a:ea typeface="Calibri" charset="0"/>
                         <a:cs typeface="Calibri" charset="0"/>
                       </a:endParaRPr>
                     </a:p>
                   </a:txBody>
-                  <a:tcPr marL="36576" marR="36576" marT="36576" marB="36576" anchor="ctr">
+                  <a:tcPr marL="27432" marR="27432" marT="27432" marB="27432" anchor="ctr">
                     <a:lnL w="6350" cap="flat" cmpd="sng" algn="ctr">
                       <a:solidFill>
                         <a:srgbClr val="BFBFBF"/>
@@ -13852,7 +13864,7 @@
                         <a:buNone/>
                       </a:pPr>
                       <a:r>
-                        <a:rPr lang="en-US" sz="1050" dirty="0">
+                        <a:rPr lang="en-US" sz="1000" dirty="0">
                           <a:solidFill>
                             <a:srgbClr val="1F1F1F"/>
                           </a:solidFill>
@@ -13860,16 +13872,16 @@
                           <a:ea typeface="Calibri" pitchFamily="34" charset="-122"/>
                           <a:cs typeface="Calibri" pitchFamily="34" charset="-120"/>
                         </a:rPr>
-                        <a:t>0.712</a:t>
+                        <a:t>0.779</a:t>
                       </a:r>
-                      <a:endParaRPr lang="en-US" sz="1050" dirty="0">
+                      <a:endParaRPr lang="en-US" sz="1000" dirty="0">
                         <a:latin typeface="Calibri" charset="0"/>
                         <a:ea typeface="Calibri" charset="0"/>
                         <a:cs typeface="Calibri" charset="0"/>
                       </a:endParaRPr>
                     </a:p>
                   </a:txBody>
-                  <a:tcPr marL="36576" marR="36576" marT="36576" marB="36576" anchor="ctr">
+                  <a:tcPr marL="27432" marR="27432" marT="27432" marB="27432" anchor="ctr">
                     <a:lnL w="6350" cap="flat" cmpd="sng" algn="ctr">
                       <a:solidFill>
                         <a:srgbClr val="BFBFBF"/>
@@ -13917,7 +13929,7 @@
                         <a:buNone/>
                       </a:pPr>
                       <a:r>
-                        <a:rPr lang="en-US" sz="1050" dirty="0">
+                        <a:rPr lang="en-US" sz="1000" dirty="0">
                           <a:solidFill>
                             <a:srgbClr val="1F1F1F"/>
                           </a:solidFill>
@@ -13925,16 +13937,16 @@
                           <a:ea typeface="Calibri" pitchFamily="34" charset="-122"/>
                           <a:cs typeface="Calibri" pitchFamily="34" charset="-120"/>
                         </a:rPr>
-                        <a:t>0.874</a:t>
+                        <a:t>0.911</a:t>
                       </a:r>
-                      <a:endParaRPr lang="en-US" sz="1050" dirty="0">
+                      <a:endParaRPr lang="en-US" sz="1000" dirty="0">
                         <a:latin typeface="Calibri" charset="0"/>
                         <a:ea typeface="Calibri" charset="0"/>
                         <a:cs typeface="Calibri" charset="0"/>
                       </a:endParaRPr>
                     </a:p>
                   </a:txBody>
-                  <a:tcPr marL="36576" marR="36576" marT="36576" marB="36576" anchor="ctr">
+                  <a:tcPr marL="27432" marR="27432" marT="27432" marB="27432" anchor="ctr">
                     <a:lnL w="6350" cap="flat" cmpd="sng" algn="ctr">
                       <a:solidFill>
                         <a:srgbClr val="BFBFBF"/>
@@ -13982,7 +13994,7 @@
                         <a:buNone/>
                       </a:pPr>
                       <a:r>
-                        <a:rPr lang="en-US" sz="1050" dirty="0">
+                        <a:rPr lang="en-US" sz="1000" dirty="0">
                           <a:solidFill>
                             <a:srgbClr val="1F1F1F"/>
                           </a:solidFill>
@@ -13990,16 +14002,16 @@
                           <a:ea typeface="Calibri" pitchFamily="34" charset="-122"/>
                           <a:cs typeface="Calibri" pitchFamily="34" charset="-120"/>
                         </a:rPr>
-                        <a:t>0.933</a:t>
+                        <a:t>0.958</a:t>
                       </a:r>
-                      <a:endParaRPr lang="en-US" sz="1050" dirty="0">
+                      <a:endParaRPr lang="en-US" sz="1000" dirty="0">
                         <a:latin typeface="Calibri" charset="0"/>
                         <a:ea typeface="Calibri" charset="0"/>
                         <a:cs typeface="Calibri" charset="0"/>
                       </a:endParaRPr>
                     </a:p>
                   </a:txBody>
-                  <a:tcPr marL="36576" marR="36576" marT="36576" marB="36576" anchor="ctr">
+                  <a:tcPr marL="27432" marR="27432" marT="27432" marB="27432" anchor="ctr">
                     <a:lnL w="6350" cap="flat" cmpd="sng" algn="ctr">
                       <a:solidFill>
                         <a:srgbClr val="BFBFBF"/>
@@ -14047,7 +14059,7 @@
                         <a:buNone/>
                       </a:pPr>
                       <a:r>
-                        <a:rPr lang="en-US" sz="1050" dirty="0">
+                        <a:rPr lang="en-US" sz="1000" dirty="0">
                           <a:solidFill>
                             <a:srgbClr val="1F1F1F"/>
                           </a:solidFill>
@@ -14055,16 +14067,16 @@
                           <a:ea typeface="Calibri" pitchFamily="34" charset="-122"/>
                           <a:cs typeface="Calibri" pitchFamily="34" charset="-120"/>
                         </a:rPr>
-                        <a:t>0.921</a:t>
+                        <a:t>1.000</a:t>
                       </a:r>
-                      <a:endParaRPr lang="en-US" sz="1050" dirty="0">
+                      <a:endParaRPr lang="en-US" sz="1000" dirty="0">
                         <a:latin typeface="Calibri" charset="0"/>
                         <a:ea typeface="Calibri" charset="0"/>
                         <a:cs typeface="Calibri" charset="0"/>
                       </a:endParaRPr>
                     </a:p>
                   </a:txBody>
-                  <a:tcPr marL="36576" marR="36576" marT="36576" marB="36576" anchor="ctr">
+                  <a:tcPr marL="27432" marR="27432" marT="27432" marB="27432" anchor="ctr">
                     <a:lnL w="6350" cap="flat" cmpd="sng" algn="ctr">
                       <a:solidFill>
                         <a:srgbClr val="BFBFBF"/>
@@ -14104,7 +14116,7 @@
                   </a:tcPr>
                 </a:tc>
               </a:tr>
-              <a:tr h="301752">
+              <a:tr h="274320">
                 <a:tc>
                   <a:txBody>
                     <a:bodyPr/>
@@ -14114,7 +14126,7 @@
                         <a:buNone/>
                       </a:pPr>
                       <a:r>
-                        <a:rPr lang="en-US" sz="1050" dirty="0">
+                        <a:rPr lang="en-US" sz="1000" dirty="0">
                           <a:solidFill>
                             <a:srgbClr val="1F1F1F"/>
                           </a:solidFill>
@@ -14122,16 +14134,16 @@
                           <a:ea typeface="Calibri" pitchFamily="34" charset="-122"/>
                           <a:cs typeface="Calibri" pitchFamily="34" charset="-120"/>
                         </a:rPr>
-                        <a:t>Random Forest (tuned, 12 features)</a:t>
+                        <a:t>Random Forest (tuned for recall)</a:t>
                       </a:r>
-                      <a:endParaRPr lang="en-US" sz="1050" dirty="0">
+                      <a:endParaRPr lang="en-US" sz="1000" dirty="0">
                         <a:latin typeface="Calibri" charset="0"/>
                         <a:ea typeface="Calibri" charset="0"/>
                         <a:cs typeface="Calibri" charset="0"/>
                       </a:endParaRPr>
                     </a:p>
                   </a:txBody>
-                  <a:tcPr marL="36576" marR="36576" marT="36576" marB="36576" anchor="ctr">
+                  <a:tcPr marL="27432" marR="27432" marT="27432" marB="27432" anchor="ctr">
                     <a:lnL w="6350" cap="flat" cmpd="sng" algn="ctr">
                       <a:solidFill>
                         <a:srgbClr val="BFBFBF"/>
@@ -14179,7 +14191,7 @@
                         <a:buNone/>
                       </a:pPr>
                       <a:r>
-                        <a:rPr lang="en-US" sz="1050" dirty="0">
+                        <a:rPr lang="en-US" sz="1000" dirty="0">
                           <a:solidFill>
                             <a:srgbClr val="1F1F1F"/>
                           </a:solidFill>
@@ -14187,16 +14199,16 @@
                           <a:ea typeface="Calibri" pitchFamily="34" charset="-122"/>
                           <a:cs typeface="Calibri" pitchFamily="34" charset="-120"/>
                         </a:rPr>
-                        <a:t>0.782</a:t>
+                        <a:t>0.784</a:t>
                       </a:r>
-                      <a:endParaRPr lang="en-US" sz="1050" dirty="0">
+                      <a:endParaRPr lang="en-US" sz="1000" dirty="0">
                         <a:latin typeface="Calibri" charset="0"/>
                         <a:ea typeface="Calibri" charset="0"/>
                         <a:cs typeface="Calibri" charset="0"/>
                       </a:endParaRPr>
                     </a:p>
                   </a:txBody>
-                  <a:tcPr marL="36576" marR="36576" marT="36576" marB="36576" anchor="ctr">
+                  <a:tcPr marL="27432" marR="27432" marT="27432" marB="27432" anchor="ctr">
                     <a:lnL w="6350" cap="flat" cmpd="sng" algn="ctr">
                       <a:solidFill>
                         <a:srgbClr val="BFBFBF"/>
@@ -14244,7 +14256,7 @@
                         <a:buNone/>
                       </a:pPr>
                       <a:r>
-                        <a:rPr lang="en-US" sz="1050" dirty="0">
+                        <a:rPr lang="en-US" sz="1000" dirty="0">
                           <a:solidFill>
                             <a:srgbClr val="1F1F1F"/>
                           </a:solidFill>
@@ -14252,16 +14264,16 @@
                           <a:ea typeface="Calibri" pitchFamily="34" charset="-122"/>
                           <a:cs typeface="Calibri" pitchFamily="34" charset="-120"/>
                         </a:rPr>
-                        <a:t>0.664</a:t>
+                        <a:t>0.653</a:t>
                       </a:r>
-                      <a:endParaRPr lang="en-US" sz="1050" dirty="0">
+                      <a:endParaRPr lang="en-US" sz="1000" dirty="0">
                         <a:latin typeface="Calibri" charset="0"/>
                         <a:ea typeface="Calibri" charset="0"/>
                         <a:cs typeface="Calibri" charset="0"/>
                       </a:endParaRPr>
                     </a:p>
                   </a:txBody>
-                  <a:tcPr marL="36576" marR="36576" marT="36576" marB="36576" anchor="ctr">
+                  <a:tcPr marL="27432" marR="27432" marT="27432" marB="27432" anchor="ctr">
                     <a:lnL w="6350" cap="flat" cmpd="sng" algn="ctr">
                       <a:solidFill>
                         <a:srgbClr val="BFBFBF"/>
@@ -14309,7 +14321,7 @@
                         <a:buNone/>
                       </a:pPr>
                       <a:r>
-                        <a:rPr lang="en-US" sz="1050" dirty="0">
+                        <a:rPr lang="en-US" sz="1000" dirty="0">
                           <a:solidFill>
                             <a:srgbClr val="1F1F1F"/>
                           </a:solidFill>
@@ -14317,16 +14329,16 @@
                           <a:ea typeface="Calibri" pitchFamily="34" charset="-122"/>
                           <a:cs typeface="Calibri" pitchFamily="34" charset="-120"/>
                         </a:rPr>
-                        <a:t>0.718</a:t>
+                        <a:t>0.712</a:t>
                       </a:r>
-                      <a:endParaRPr lang="en-US" sz="1050" dirty="0">
+                      <a:endParaRPr lang="en-US" sz="1000" dirty="0">
                         <a:latin typeface="Calibri" charset="0"/>
                         <a:ea typeface="Calibri" charset="0"/>
                         <a:cs typeface="Calibri" charset="0"/>
                       </a:endParaRPr>
                     </a:p>
                   </a:txBody>
-                  <a:tcPr marL="36576" marR="36576" marT="36576" marB="36576" anchor="ctr">
+                  <a:tcPr marL="27432" marR="27432" marT="27432" marB="27432" anchor="ctr">
                     <a:lnL w="6350" cap="flat" cmpd="sng" algn="ctr">
                       <a:solidFill>
                         <a:srgbClr val="BFBFBF"/>
@@ -14374,7 +14386,7 @@
                         <a:buNone/>
                       </a:pPr>
                       <a:r>
-                        <a:rPr lang="en-US" sz="1050" dirty="0">
+                        <a:rPr lang="en-US" sz="1000" dirty="0">
                           <a:solidFill>
                             <a:srgbClr val="1F1F1F"/>
                           </a:solidFill>
@@ -14382,16 +14394,16 @@
                           <a:ea typeface="Calibri" pitchFamily="34" charset="-122"/>
                           <a:cs typeface="Calibri" pitchFamily="34" charset="-120"/>
                         </a:rPr>
-                        <a:t>0.878</a:t>
+                        <a:t>0.874</a:t>
                       </a:r>
-                      <a:endParaRPr lang="en-US" sz="1050" dirty="0">
+                      <a:endParaRPr lang="en-US" sz="1000" dirty="0">
                         <a:latin typeface="Calibri" charset="0"/>
                         <a:ea typeface="Calibri" charset="0"/>
                         <a:cs typeface="Calibri" charset="0"/>
                       </a:endParaRPr>
                     </a:p>
                   </a:txBody>
-                  <a:tcPr marL="36576" marR="36576" marT="36576" marB="36576" anchor="ctr">
+                  <a:tcPr marL="27432" marR="27432" marT="27432" marB="27432" anchor="ctr">
                     <a:lnL w="6350" cap="flat" cmpd="sng" algn="ctr">
                       <a:solidFill>
                         <a:srgbClr val="BFBFBF"/>
@@ -14439,7 +14451,7 @@
                         <a:buNone/>
                       </a:pPr>
                       <a:r>
-                        <a:rPr lang="en-US" sz="1050" dirty="0">
+                        <a:rPr lang="en-US" sz="1000" dirty="0">
                           <a:solidFill>
                             <a:srgbClr val="1F1F1F"/>
                           </a:solidFill>
@@ -14447,16 +14459,16 @@
                           <a:ea typeface="Calibri" pitchFamily="34" charset="-122"/>
                           <a:cs typeface="Calibri" pitchFamily="34" charset="-120"/>
                         </a:rPr>
-                        <a:t>0.928</a:t>
+                        <a:t>0.933</a:t>
                       </a:r>
-                      <a:endParaRPr lang="en-US" sz="1050" dirty="0">
+                      <a:endParaRPr lang="en-US" sz="1000" dirty="0">
                         <a:latin typeface="Calibri" charset="0"/>
                         <a:ea typeface="Calibri" charset="0"/>
                         <a:cs typeface="Calibri" charset="0"/>
                       </a:endParaRPr>
                     </a:p>
                   </a:txBody>
-                  <a:tcPr marL="36576" marR="36576" marT="36576" marB="36576" anchor="ctr">
+                  <a:tcPr marL="27432" marR="27432" marT="27432" marB="27432" anchor="ctr">
                     <a:lnL w="6350" cap="flat" cmpd="sng" algn="ctr">
                       <a:solidFill>
                         <a:srgbClr val="BFBFBF"/>
@@ -14504,7 +14516,7 @@
                         <a:buNone/>
                       </a:pPr>
                       <a:r>
-                        <a:rPr lang="en-US" sz="1050" dirty="0">
+                        <a:rPr lang="en-US" sz="1000" dirty="0">
                           <a:solidFill>
                             <a:srgbClr val="1F1F1F"/>
                           </a:solidFill>
@@ -14512,16 +14524,16 @@
                           <a:ea typeface="Calibri" pitchFamily="34" charset="-122"/>
                           <a:cs typeface="Calibri" pitchFamily="34" charset="-120"/>
                         </a:rPr>
-                        <a:t>0.917</a:t>
+                        <a:t>0.921</a:t>
                       </a:r>
-                      <a:endParaRPr lang="en-US" sz="1050" dirty="0">
+                      <a:endParaRPr lang="en-US" sz="1000" dirty="0">
                         <a:latin typeface="Calibri" charset="0"/>
                         <a:ea typeface="Calibri" charset="0"/>
                         <a:cs typeface="Calibri" charset="0"/>
                       </a:endParaRPr>
                     </a:p>
                   </a:txBody>
-                  <a:tcPr marL="36576" marR="36576" marT="36576" marB="36576" anchor="ctr">
+                  <a:tcPr marL="27432" marR="27432" marT="27432" marB="27432" anchor="ctr">
                     <a:lnL w="6350" cap="flat" cmpd="sng" algn="ctr">
                       <a:solidFill>
                         <a:srgbClr val="BFBFBF"/>
@@ -14561,7 +14573,7 @@
                   </a:tcPr>
                 </a:tc>
               </a:tr>
-              <a:tr h="301752">
+              <a:tr h="274320">
                 <a:tc>
                   <a:txBody>
                     <a:bodyPr/>
@@ -14571,7 +14583,7 @@
                         <a:buNone/>
                       </a:pPr>
                       <a:r>
-                        <a:rPr lang="en-US" sz="1050" b="1" dirty="0">
+                        <a:rPr lang="en-US" sz="1000" dirty="0">
                           <a:solidFill>
                             <a:srgbClr val="1F1F1F"/>
                           </a:solidFill>
@@ -14579,16 +14591,16 @@
                           <a:ea typeface="Calibri" pitchFamily="34" charset="-122"/>
                           <a:cs typeface="Calibri" pitchFamily="34" charset="-120"/>
                         </a:rPr>
-                        <a:t>Proposed: RF class weights, threshold 0.25</a:t>
+                        <a:t>Random Forest (tuned, 12 features)</a:t>
                       </a:r>
-                      <a:endParaRPr lang="en-US" sz="1050" dirty="0">
+                      <a:endParaRPr lang="en-US" sz="1000" dirty="0">
                         <a:latin typeface="Calibri" charset="0"/>
                         <a:ea typeface="Calibri" charset="0"/>
                         <a:cs typeface="Calibri" charset="0"/>
                       </a:endParaRPr>
                     </a:p>
                   </a:txBody>
-                  <a:tcPr marL="36576" marR="36576" marT="36576" marB="36576" anchor="ctr">
+                  <a:tcPr marL="27432" marR="27432" marT="27432" marB="27432" anchor="ctr">
                     <a:lnL w="6350" cap="flat" cmpd="sng" algn="ctr">
                       <a:solidFill>
                         <a:srgbClr val="BFBFBF"/>
@@ -14636,7 +14648,7 @@
                         <a:buNone/>
                       </a:pPr>
                       <a:r>
-                        <a:rPr lang="en-US" sz="1050" b="1" dirty="0">
+                        <a:rPr lang="en-US" sz="1000" dirty="0">
                           <a:solidFill>
                             <a:srgbClr val="1F1F1F"/>
                           </a:solidFill>
@@ -14644,16 +14656,16 @@
                           <a:ea typeface="Calibri" pitchFamily="34" charset="-122"/>
                           <a:cs typeface="Calibri" pitchFamily="34" charset="-120"/>
                         </a:rPr>
-                        <a:t>0.933</a:t>
+                        <a:t>0.782</a:t>
                       </a:r>
-                      <a:endParaRPr lang="en-US" sz="1050" dirty="0">
+                      <a:endParaRPr lang="en-US" sz="1000" dirty="0">
                         <a:latin typeface="Calibri" charset="0"/>
                         <a:ea typeface="Calibri" charset="0"/>
                         <a:cs typeface="Calibri" charset="0"/>
                       </a:endParaRPr>
                     </a:p>
                   </a:txBody>
-                  <a:tcPr marL="36576" marR="36576" marT="36576" marB="36576" anchor="ctr">
+                  <a:tcPr marL="27432" marR="27432" marT="27432" marB="27432" anchor="ctr">
                     <a:lnL w="6350" cap="flat" cmpd="sng" algn="ctr">
                       <a:solidFill>
                         <a:srgbClr val="BFBFBF"/>
@@ -14701,7 +14713,7 @@
                         <a:buNone/>
                       </a:pPr>
                       <a:r>
-                        <a:rPr lang="en-US" sz="1050" b="1" dirty="0">
+                        <a:rPr lang="en-US" sz="1000" dirty="0">
                           <a:solidFill>
                             <a:srgbClr val="1F1F1F"/>
                           </a:solidFill>
@@ -14709,16 +14721,16 @@
                           <a:ea typeface="Calibri" pitchFamily="34" charset="-122"/>
                           <a:cs typeface="Calibri" pitchFamily="34" charset="-120"/>
                         </a:rPr>
-                        <a:t>0.670</a:t>
+                        <a:t>0.664</a:t>
                       </a:r>
-                      <a:endParaRPr lang="en-US" sz="1050" dirty="0">
+                      <a:endParaRPr lang="en-US" sz="1000" dirty="0">
                         <a:latin typeface="Calibri" charset="0"/>
                         <a:ea typeface="Calibri" charset="0"/>
                         <a:cs typeface="Calibri" charset="0"/>
                       </a:endParaRPr>
                     </a:p>
                   </a:txBody>
-                  <a:tcPr marL="36576" marR="36576" marT="36576" marB="36576" anchor="ctr">
+                  <a:tcPr marL="27432" marR="27432" marT="27432" marB="27432" anchor="ctr">
                     <a:lnL w="6350" cap="flat" cmpd="sng" algn="ctr">
                       <a:solidFill>
                         <a:srgbClr val="BFBFBF"/>
@@ -14766,7 +14778,7 @@
                         <a:buNone/>
                       </a:pPr>
                       <a:r>
-                        <a:rPr lang="en-US" sz="1050" b="1" dirty="0">
+                        <a:rPr lang="en-US" sz="1000" dirty="0">
                           <a:solidFill>
                             <a:srgbClr val="1F1F1F"/>
                           </a:solidFill>
@@ -14774,16 +14786,16 @@
                           <a:ea typeface="Calibri" pitchFamily="34" charset="-122"/>
                           <a:cs typeface="Calibri" pitchFamily="34" charset="-120"/>
                         </a:rPr>
-                        <a:t>0.780</a:t>
+                        <a:t>0.718</a:t>
                       </a:r>
-                      <a:endParaRPr lang="en-US" sz="1050" dirty="0">
+                      <a:endParaRPr lang="en-US" sz="1000" dirty="0">
                         <a:latin typeface="Calibri" charset="0"/>
                         <a:ea typeface="Calibri" charset="0"/>
                         <a:cs typeface="Calibri" charset="0"/>
                       </a:endParaRPr>
                     </a:p>
                   </a:txBody>
-                  <a:tcPr marL="36576" marR="36576" marT="36576" marB="36576" anchor="ctr">
+                  <a:tcPr marL="27432" marR="27432" marT="27432" marB="27432" anchor="ctr">
                     <a:lnL w="6350" cap="flat" cmpd="sng" algn="ctr">
                       <a:solidFill>
                         <a:srgbClr val="BFBFBF"/>
@@ -14831,7 +14843,7 @@
                         <a:buNone/>
                       </a:pPr>
                       <a:r>
-                        <a:rPr lang="en-US" sz="1050" b="1" dirty="0">
+                        <a:rPr lang="en-US" sz="1000" dirty="0">
                           <a:solidFill>
                             <a:srgbClr val="1F1F1F"/>
                           </a:solidFill>
@@ -14839,16 +14851,16 @@
                           <a:ea typeface="Calibri" pitchFamily="34" charset="-122"/>
                           <a:cs typeface="Calibri" pitchFamily="34" charset="-120"/>
                         </a:rPr>
-                        <a:t>0.895</a:t>
+                        <a:t>0.878</a:t>
                       </a:r>
-                      <a:endParaRPr lang="en-US" sz="1050" dirty="0">
+                      <a:endParaRPr lang="en-US" sz="1000" dirty="0">
                         <a:latin typeface="Calibri" charset="0"/>
                         <a:ea typeface="Calibri" charset="0"/>
                         <a:cs typeface="Calibri" charset="0"/>
                       </a:endParaRPr>
                     </a:p>
                   </a:txBody>
-                  <a:tcPr marL="36576" marR="36576" marT="36576" marB="36576" anchor="ctr">
+                  <a:tcPr marL="27432" marR="27432" marT="27432" marB="27432" anchor="ctr">
                     <a:lnL w="6350" cap="flat" cmpd="sng" algn="ctr">
                       <a:solidFill>
                         <a:srgbClr val="BFBFBF"/>
@@ -14896,7 +14908,7 @@
                         <a:buNone/>
                       </a:pPr>
                       <a:r>
-                        <a:rPr lang="en-US" sz="1050" b="1" dirty="0">
+                        <a:rPr lang="en-US" sz="1000" dirty="0">
                           <a:solidFill>
                             <a:srgbClr val="1F1F1F"/>
                           </a:solidFill>
@@ -14904,16 +14916,16 @@
                           <a:ea typeface="Calibri" pitchFamily="34" charset="-122"/>
                           <a:cs typeface="Calibri" pitchFamily="34" charset="-120"/>
                         </a:rPr>
-                        <a:t>0.958</a:t>
+                        <a:t>0.928</a:t>
                       </a:r>
-                      <a:endParaRPr lang="en-US" sz="1050" dirty="0">
+                      <a:endParaRPr lang="en-US" sz="1000" dirty="0">
                         <a:latin typeface="Calibri" charset="0"/>
                         <a:ea typeface="Calibri" charset="0"/>
                         <a:cs typeface="Calibri" charset="0"/>
                       </a:endParaRPr>
                     </a:p>
                   </a:txBody>
-                  <a:tcPr marL="36576" marR="36576" marT="36576" marB="36576" anchor="ctr">
+                  <a:tcPr marL="27432" marR="27432" marT="27432" marB="27432" anchor="ctr">
                     <a:lnL w="6350" cap="flat" cmpd="sng" algn="ctr">
                       <a:solidFill>
                         <a:srgbClr val="BFBFBF"/>
@@ -14961,7 +14973,464 @@
                         <a:buNone/>
                       </a:pPr>
                       <a:r>
-                        <a:rPr lang="en-US" sz="1050" dirty="0">
+                        <a:rPr lang="en-US" sz="1000" dirty="0">
+                          <a:solidFill>
+                            <a:srgbClr val="1F1F1F"/>
+                          </a:solidFill>
+                          <a:latin typeface="Calibri" pitchFamily="34" charset="0"/>
+                          <a:ea typeface="Calibri" pitchFamily="34" charset="-122"/>
+                          <a:cs typeface="Calibri" pitchFamily="34" charset="-120"/>
+                        </a:rPr>
+                        <a:t>0.917</a:t>
+                      </a:r>
+                      <a:endParaRPr lang="en-US" sz="1000" dirty="0">
+                        <a:latin typeface="Calibri" charset="0"/>
+                        <a:ea typeface="Calibri" charset="0"/>
+                        <a:cs typeface="Calibri" charset="0"/>
+                      </a:endParaRPr>
+                    </a:p>
+                  </a:txBody>
+                  <a:tcPr marL="27432" marR="27432" marT="27432" marB="27432" anchor="ctr">
+                    <a:lnL w="6350" cap="flat" cmpd="sng" algn="ctr">
+                      <a:solidFill>
+                        <a:srgbClr val="BFBFBF"/>
+                      </a:solidFill>
+                      <a:prstDash val="solid"/>
+                      <a:round/>
+                      <a:headEnd type="none" w="med" len="med"/>
+                      <a:tailEnd type="none" w="med" len="med"/>
+                    </a:lnL>
+                    <a:lnR w="6350" cap="flat" cmpd="sng" algn="ctr">
+                      <a:solidFill>
+                        <a:srgbClr val="BFBFBF"/>
+                      </a:solidFill>
+                      <a:prstDash val="solid"/>
+                      <a:round/>
+                      <a:headEnd type="none" w="med" len="med"/>
+                      <a:tailEnd type="none" w="med" len="med"/>
+                    </a:lnR>
+                    <a:lnT w="6350" cap="flat" cmpd="sng" algn="ctr">
+                      <a:solidFill>
+                        <a:srgbClr val="BFBFBF"/>
+                      </a:solidFill>
+                      <a:prstDash val="solid"/>
+                      <a:round/>
+                      <a:headEnd type="none" w="med" len="med"/>
+                      <a:tailEnd type="none" w="med" len="med"/>
+                    </a:lnT>
+                    <a:lnB w="6350" cap="flat" cmpd="sng" algn="ctr">
+                      <a:solidFill>
+                        <a:srgbClr val="BFBFBF"/>
+                      </a:solidFill>
+                      <a:prstDash val="solid"/>
+                      <a:round/>
+                      <a:headEnd type="none" w="med" len="med"/>
+                      <a:tailEnd type="none" w="med" len="med"/>
+                    </a:lnB>
+                  </a:tcPr>
+                </a:tc>
+              </a:tr>
+              <a:tr h="274320">
+                <a:tc>
+                  <a:txBody>
+                    <a:bodyPr/>
+                    <a:lstStyle/>
+                    <a:p>
+                      <a:pPr algn="l" indent="0" marL="0">
+                        <a:buNone/>
+                      </a:pPr>
+                      <a:r>
+                        <a:rPr lang="en-US" sz="1000" b="1" dirty="0">
+                          <a:solidFill>
+                            <a:srgbClr val="1F1F1F"/>
+                          </a:solidFill>
+                          <a:latin typeface="Calibri" pitchFamily="34" charset="0"/>
+                          <a:ea typeface="Calibri" pitchFamily="34" charset="-122"/>
+                          <a:cs typeface="Calibri" pitchFamily="34" charset="-120"/>
+                        </a:rPr>
+                        <a:t>Proposed: RF class weights, threshold 0.25</a:t>
+                      </a:r>
+                      <a:endParaRPr lang="en-US" sz="1000" dirty="0">
+                        <a:latin typeface="Calibri" charset="0"/>
+                        <a:ea typeface="Calibri" charset="0"/>
+                        <a:cs typeface="Calibri" charset="0"/>
+                      </a:endParaRPr>
+                    </a:p>
+                  </a:txBody>
+                  <a:tcPr marL="27432" marR="27432" marT="27432" marB="27432" anchor="ctr">
+                    <a:lnL w="6350" cap="flat" cmpd="sng" algn="ctr">
+                      <a:solidFill>
+                        <a:srgbClr val="BFBFBF"/>
+                      </a:solidFill>
+                      <a:prstDash val="solid"/>
+                      <a:round/>
+                      <a:headEnd type="none" w="med" len="med"/>
+                      <a:tailEnd type="none" w="med" len="med"/>
+                    </a:lnL>
+                    <a:lnR w="6350" cap="flat" cmpd="sng" algn="ctr">
+                      <a:solidFill>
+                        <a:srgbClr val="BFBFBF"/>
+                      </a:solidFill>
+                      <a:prstDash val="solid"/>
+                      <a:round/>
+                      <a:headEnd type="none" w="med" len="med"/>
+                      <a:tailEnd type="none" w="med" len="med"/>
+                    </a:lnR>
+                    <a:lnT w="6350" cap="flat" cmpd="sng" algn="ctr">
+                      <a:solidFill>
+                        <a:srgbClr val="BFBFBF"/>
+                      </a:solidFill>
+                      <a:prstDash val="solid"/>
+                      <a:round/>
+                      <a:headEnd type="none" w="med" len="med"/>
+                      <a:tailEnd type="none" w="med" len="med"/>
+                    </a:lnT>
+                    <a:lnB w="6350" cap="flat" cmpd="sng" algn="ctr">
+                      <a:solidFill>
+                        <a:srgbClr val="BFBFBF"/>
+                      </a:solidFill>
+                      <a:prstDash val="solid"/>
+                      <a:round/>
+                      <a:headEnd type="none" w="med" len="med"/>
+                      <a:tailEnd type="none" w="med" len="med"/>
+                    </a:lnB>
+                  </a:tcPr>
+                </a:tc>
+                <a:tc>
+                  <a:txBody>
+                    <a:bodyPr/>
+                    <a:lstStyle/>
+                    <a:p>
+                      <a:pPr algn="l" indent="0" marL="0">
+                        <a:buNone/>
+                      </a:pPr>
+                      <a:r>
+                        <a:rPr lang="en-US" sz="1000" b="1" dirty="0">
+                          <a:solidFill>
+                            <a:srgbClr val="1F1F1F"/>
+                          </a:solidFill>
+                          <a:latin typeface="Calibri" pitchFamily="34" charset="0"/>
+                          <a:ea typeface="Calibri" pitchFamily="34" charset="-122"/>
+                          <a:cs typeface="Calibri" pitchFamily="34" charset="-120"/>
+                        </a:rPr>
+                        <a:t>0.933</a:t>
+                      </a:r>
+                      <a:endParaRPr lang="en-US" sz="1000" dirty="0">
+                        <a:latin typeface="Calibri" charset="0"/>
+                        <a:ea typeface="Calibri" charset="0"/>
+                        <a:cs typeface="Calibri" charset="0"/>
+                      </a:endParaRPr>
+                    </a:p>
+                  </a:txBody>
+                  <a:tcPr marL="27432" marR="27432" marT="27432" marB="27432" anchor="ctr">
+                    <a:lnL w="6350" cap="flat" cmpd="sng" algn="ctr">
+                      <a:solidFill>
+                        <a:srgbClr val="BFBFBF"/>
+                      </a:solidFill>
+                      <a:prstDash val="solid"/>
+                      <a:round/>
+                      <a:headEnd type="none" w="med" len="med"/>
+                      <a:tailEnd type="none" w="med" len="med"/>
+                    </a:lnL>
+                    <a:lnR w="6350" cap="flat" cmpd="sng" algn="ctr">
+                      <a:solidFill>
+                        <a:srgbClr val="BFBFBF"/>
+                      </a:solidFill>
+                      <a:prstDash val="solid"/>
+                      <a:round/>
+                      <a:headEnd type="none" w="med" len="med"/>
+                      <a:tailEnd type="none" w="med" len="med"/>
+                    </a:lnR>
+                    <a:lnT w="6350" cap="flat" cmpd="sng" algn="ctr">
+                      <a:solidFill>
+                        <a:srgbClr val="BFBFBF"/>
+                      </a:solidFill>
+                      <a:prstDash val="solid"/>
+                      <a:round/>
+                      <a:headEnd type="none" w="med" len="med"/>
+                      <a:tailEnd type="none" w="med" len="med"/>
+                    </a:lnT>
+                    <a:lnB w="6350" cap="flat" cmpd="sng" algn="ctr">
+                      <a:solidFill>
+                        <a:srgbClr val="BFBFBF"/>
+                      </a:solidFill>
+                      <a:prstDash val="solid"/>
+                      <a:round/>
+                      <a:headEnd type="none" w="med" len="med"/>
+                      <a:tailEnd type="none" w="med" len="med"/>
+                    </a:lnB>
+                  </a:tcPr>
+                </a:tc>
+                <a:tc>
+                  <a:txBody>
+                    <a:bodyPr/>
+                    <a:lstStyle/>
+                    <a:p>
+                      <a:pPr algn="l" indent="0" marL="0">
+                        <a:buNone/>
+                      </a:pPr>
+                      <a:r>
+                        <a:rPr lang="en-US" sz="1000" b="1" dirty="0">
+                          <a:solidFill>
+                            <a:srgbClr val="1F1F1F"/>
+                          </a:solidFill>
+                          <a:latin typeface="Calibri" pitchFamily="34" charset="0"/>
+                          <a:ea typeface="Calibri" pitchFamily="34" charset="-122"/>
+                          <a:cs typeface="Calibri" pitchFamily="34" charset="-120"/>
+                        </a:rPr>
+                        <a:t>0.670</a:t>
+                      </a:r>
+                      <a:endParaRPr lang="en-US" sz="1000" dirty="0">
+                        <a:latin typeface="Calibri" charset="0"/>
+                        <a:ea typeface="Calibri" charset="0"/>
+                        <a:cs typeface="Calibri" charset="0"/>
+                      </a:endParaRPr>
+                    </a:p>
+                  </a:txBody>
+                  <a:tcPr marL="27432" marR="27432" marT="27432" marB="27432" anchor="ctr">
+                    <a:lnL w="6350" cap="flat" cmpd="sng" algn="ctr">
+                      <a:solidFill>
+                        <a:srgbClr val="BFBFBF"/>
+                      </a:solidFill>
+                      <a:prstDash val="solid"/>
+                      <a:round/>
+                      <a:headEnd type="none" w="med" len="med"/>
+                      <a:tailEnd type="none" w="med" len="med"/>
+                    </a:lnL>
+                    <a:lnR w="6350" cap="flat" cmpd="sng" algn="ctr">
+                      <a:solidFill>
+                        <a:srgbClr val="BFBFBF"/>
+                      </a:solidFill>
+                      <a:prstDash val="solid"/>
+                      <a:round/>
+                      <a:headEnd type="none" w="med" len="med"/>
+                      <a:tailEnd type="none" w="med" len="med"/>
+                    </a:lnR>
+                    <a:lnT w="6350" cap="flat" cmpd="sng" algn="ctr">
+                      <a:solidFill>
+                        <a:srgbClr val="BFBFBF"/>
+                      </a:solidFill>
+                      <a:prstDash val="solid"/>
+                      <a:round/>
+                      <a:headEnd type="none" w="med" len="med"/>
+                      <a:tailEnd type="none" w="med" len="med"/>
+                    </a:lnT>
+                    <a:lnB w="6350" cap="flat" cmpd="sng" algn="ctr">
+                      <a:solidFill>
+                        <a:srgbClr val="BFBFBF"/>
+                      </a:solidFill>
+                      <a:prstDash val="solid"/>
+                      <a:round/>
+                      <a:headEnd type="none" w="med" len="med"/>
+                      <a:tailEnd type="none" w="med" len="med"/>
+                    </a:lnB>
+                  </a:tcPr>
+                </a:tc>
+                <a:tc>
+                  <a:txBody>
+                    <a:bodyPr/>
+                    <a:lstStyle/>
+                    <a:p>
+                      <a:pPr algn="l" indent="0" marL="0">
+                        <a:buNone/>
+                      </a:pPr>
+                      <a:r>
+                        <a:rPr lang="en-US" sz="1000" b="1" dirty="0">
+                          <a:solidFill>
+                            <a:srgbClr val="1F1F1F"/>
+                          </a:solidFill>
+                          <a:latin typeface="Calibri" pitchFamily="34" charset="0"/>
+                          <a:ea typeface="Calibri" pitchFamily="34" charset="-122"/>
+                          <a:cs typeface="Calibri" pitchFamily="34" charset="-120"/>
+                        </a:rPr>
+                        <a:t>0.780</a:t>
+                      </a:r>
+                      <a:endParaRPr lang="en-US" sz="1000" dirty="0">
+                        <a:latin typeface="Calibri" charset="0"/>
+                        <a:ea typeface="Calibri" charset="0"/>
+                        <a:cs typeface="Calibri" charset="0"/>
+                      </a:endParaRPr>
+                    </a:p>
+                  </a:txBody>
+                  <a:tcPr marL="27432" marR="27432" marT="27432" marB="27432" anchor="ctr">
+                    <a:lnL w="6350" cap="flat" cmpd="sng" algn="ctr">
+                      <a:solidFill>
+                        <a:srgbClr val="BFBFBF"/>
+                      </a:solidFill>
+                      <a:prstDash val="solid"/>
+                      <a:round/>
+                      <a:headEnd type="none" w="med" len="med"/>
+                      <a:tailEnd type="none" w="med" len="med"/>
+                    </a:lnL>
+                    <a:lnR w="6350" cap="flat" cmpd="sng" algn="ctr">
+                      <a:solidFill>
+                        <a:srgbClr val="BFBFBF"/>
+                      </a:solidFill>
+                      <a:prstDash val="solid"/>
+                      <a:round/>
+                      <a:headEnd type="none" w="med" len="med"/>
+                      <a:tailEnd type="none" w="med" len="med"/>
+                    </a:lnR>
+                    <a:lnT w="6350" cap="flat" cmpd="sng" algn="ctr">
+                      <a:solidFill>
+                        <a:srgbClr val="BFBFBF"/>
+                      </a:solidFill>
+                      <a:prstDash val="solid"/>
+                      <a:round/>
+                      <a:headEnd type="none" w="med" len="med"/>
+                      <a:tailEnd type="none" w="med" len="med"/>
+                    </a:lnT>
+                    <a:lnB w="6350" cap="flat" cmpd="sng" algn="ctr">
+                      <a:solidFill>
+                        <a:srgbClr val="BFBFBF"/>
+                      </a:solidFill>
+                      <a:prstDash val="solid"/>
+                      <a:round/>
+                      <a:headEnd type="none" w="med" len="med"/>
+                      <a:tailEnd type="none" w="med" len="med"/>
+                    </a:lnB>
+                  </a:tcPr>
+                </a:tc>
+                <a:tc>
+                  <a:txBody>
+                    <a:bodyPr/>
+                    <a:lstStyle/>
+                    <a:p>
+                      <a:pPr algn="l" indent="0" marL="0">
+                        <a:buNone/>
+                      </a:pPr>
+                      <a:r>
+                        <a:rPr lang="en-US" sz="1000" b="1" dirty="0">
+                          <a:solidFill>
+                            <a:srgbClr val="1F1F1F"/>
+                          </a:solidFill>
+                          <a:latin typeface="Calibri" pitchFamily="34" charset="0"/>
+                          <a:ea typeface="Calibri" pitchFamily="34" charset="-122"/>
+                          <a:cs typeface="Calibri" pitchFamily="34" charset="-120"/>
+                        </a:rPr>
+                        <a:t>0.895</a:t>
+                      </a:r>
+                      <a:endParaRPr lang="en-US" sz="1000" dirty="0">
+                        <a:latin typeface="Calibri" charset="0"/>
+                        <a:ea typeface="Calibri" charset="0"/>
+                        <a:cs typeface="Calibri" charset="0"/>
+                      </a:endParaRPr>
+                    </a:p>
+                  </a:txBody>
+                  <a:tcPr marL="27432" marR="27432" marT="27432" marB="27432" anchor="ctr">
+                    <a:lnL w="6350" cap="flat" cmpd="sng" algn="ctr">
+                      <a:solidFill>
+                        <a:srgbClr val="BFBFBF"/>
+                      </a:solidFill>
+                      <a:prstDash val="solid"/>
+                      <a:round/>
+                      <a:headEnd type="none" w="med" len="med"/>
+                      <a:tailEnd type="none" w="med" len="med"/>
+                    </a:lnL>
+                    <a:lnR w="6350" cap="flat" cmpd="sng" algn="ctr">
+                      <a:solidFill>
+                        <a:srgbClr val="BFBFBF"/>
+                      </a:solidFill>
+                      <a:prstDash val="solid"/>
+                      <a:round/>
+                      <a:headEnd type="none" w="med" len="med"/>
+                      <a:tailEnd type="none" w="med" len="med"/>
+                    </a:lnR>
+                    <a:lnT w="6350" cap="flat" cmpd="sng" algn="ctr">
+                      <a:solidFill>
+                        <a:srgbClr val="BFBFBF"/>
+                      </a:solidFill>
+                      <a:prstDash val="solid"/>
+                      <a:round/>
+                      <a:headEnd type="none" w="med" len="med"/>
+                      <a:tailEnd type="none" w="med" len="med"/>
+                    </a:lnT>
+                    <a:lnB w="6350" cap="flat" cmpd="sng" algn="ctr">
+                      <a:solidFill>
+                        <a:srgbClr val="BFBFBF"/>
+                      </a:solidFill>
+                      <a:prstDash val="solid"/>
+                      <a:round/>
+                      <a:headEnd type="none" w="med" len="med"/>
+                      <a:tailEnd type="none" w="med" len="med"/>
+                    </a:lnB>
+                  </a:tcPr>
+                </a:tc>
+                <a:tc>
+                  <a:txBody>
+                    <a:bodyPr/>
+                    <a:lstStyle/>
+                    <a:p>
+                      <a:pPr algn="l" indent="0" marL="0">
+                        <a:buNone/>
+                      </a:pPr>
+                      <a:r>
+                        <a:rPr lang="en-US" sz="1000" b="1" dirty="0">
+                          <a:solidFill>
+                            <a:srgbClr val="1F1F1F"/>
+                          </a:solidFill>
+                          <a:latin typeface="Calibri" pitchFamily="34" charset="0"/>
+                          <a:ea typeface="Calibri" pitchFamily="34" charset="-122"/>
+                          <a:cs typeface="Calibri" pitchFamily="34" charset="-120"/>
+                        </a:rPr>
+                        <a:t>0.958</a:t>
+                      </a:r>
+                      <a:endParaRPr lang="en-US" sz="1000" dirty="0">
+                        <a:latin typeface="Calibri" charset="0"/>
+                        <a:ea typeface="Calibri" charset="0"/>
+                        <a:cs typeface="Calibri" charset="0"/>
+                      </a:endParaRPr>
+                    </a:p>
+                  </a:txBody>
+                  <a:tcPr marL="27432" marR="27432" marT="27432" marB="27432" anchor="ctr">
+                    <a:lnL w="6350" cap="flat" cmpd="sng" algn="ctr">
+                      <a:solidFill>
+                        <a:srgbClr val="BFBFBF"/>
+                      </a:solidFill>
+                      <a:prstDash val="solid"/>
+                      <a:round/>
+                      <a:headEnd type="none" w="med" len="med"/>
+                      <a:tailEnd type="none" w="med" len="med"/>
+                    </a:lnL>
+                    <a:lnR w="6350" cap="flat" cmpd="sng" algn="ctr">
+                      <a:solidFill>
+                        <a:srgbClr val="BFBFBF"/>
+                      </a:solidFill>
+                      <a:prstDash val="solid"/>
+                      <a:round/>
+                      <a:headEnd type="none" w="med" len="med"/>
+                      <a:tailEnd type="none" w="med" len="med"/>
+                    </a:lnR>
+                    <a:lnT w="6350" cap="flat" cmpd="sng" algn="ctr">
+                      <a:solidFill>
+                        <a:srgbClr val="BFBFBF"/>
+                      </a:solidFill>
+                      <a:prstDash val="solid"/>
+                      <a:round/>
+                      <a:headEnd type="none" w="med" len="med"/>
+                      <a:tailEnd type="none" w="med" len="med"/>
+                    </a:lnT>
+                    <a:lnB w="6350" cap="flat" cmpd="sng" algn="ctr">
+                      <a:solidFill>
+                        <a:srgbClr val="BFBFBF"/>
+                      </a:solidFill>
+                      <a:prstDash val="solid"/>
+                      <a:round/>
+                      <a:headEnd type="none" w="med" len="med"/>
+                      <a:tailEnd type="none" w="med" len="med"/>
+                    </a:lnB>
+                  </a:tcPr>
+                </a:tc>
+                <a:tc>
+                  <a:txBody>
+                    <a:bodyPr/>
+                    <a:lstStyle/>
+                    <a:p>
+                      <a:pPr algn="l" indent="0" marL="0">
+                        <a:buNone/>
+                      </a:pPr>
+                      <a:r>
+                        <a:rPr lang="en-US" sz="1000" dirty="0">
                           <a:solidFill>
                             <a:srgbClr val="1F1F1F"/>
                           </a:solidFill>
@@ -14971,14 +15440,14 @@
                         </a:rPr>
                         <a:t>-</a:t>
                       </a:r>
-                      <a:endParaRPr lang="en-US" sz="1050" dirty="0">
+                      <a:endParaRPr lang="en-US" sz="1000" dirty="0">
                         <a:latin typeface="Calibri" charset="0"/>
                         <a:ea typeface="Calibri" charset="0"/>
                         <a:cs typeface="Calibri" charset="0"/>
                       </a:endParaRPr>
                     </a:p>
                   </a:txBody>
-                  <a:tcPr marL="36576" marR="36576" marT="36576" marB="36576" anchor="ctr">
+                  <a:tcPr marL="27432" marR="27432" marT="27432" marB="27432" anchor="ctr">
                     <a:lnL w="6350" cap="flat" cmpd="sng" algn="ctr">
                       <a:solidFill>
                         <a:srgbClr val="BFBFBF"/>
@@ -19425,7 +19894,7 @@
                   <a:schemeClr val="tx1"/>
                 </a:solidFill>
               </a:rPr>
-              <a:t>Logistic Regression (linear benchmark), Decision Tree, Random Forest; class weights; cross-validated grid search</a:t>
+              <a:t>Logistic Regression (linear benchmark), Decision Tree, Bagging, Random Forest; class weights; cross-validated grid search</a:t>
             </a:r>
             <a:endParaRPr lang="en-US" sz="1100" dirty="0"/>
           </a:p>
@@ -21035,7 +21504,7 @@
                   <a:schemeClr val="tx1"/>
                 </a:solidFill>
               </a:rPr>
-              <a:t>Single tree vs forest: the tuned tree catches 82% but declines almost one good customer per defaulter caught (53% precision).</a:t>
+              <a:t>Single tree vs ensembles: the tuned tree catches 82% but declines almost one good customer per defaulter caught (53% precision). Bagging 200 trees lifts precision to 83% and AUC to 0.95 at 68% recall.</a:t>
             </a:r>
             <a:endParaRPr lang="en-US" sz="1200" dirty="0"/>
           </a:p>

</xml_diff>

<commit_message>
Fix slide overflow and two wording details in the deck
Co-Authored-By: Claude Fable 5.1 <noreply@anthropic.com>
Claude-Session: https://claude.ai/code/session_013FziBHdvbXYQwd5XRG4tZw
</commit_message>
<xml_diff>
--- a/presentation/Loan_Default_Prediction_Presentation.pptx
+++ b/presentation/Loan_Default_Prediction_Presentation.pptx
@@ -125,26 +125,26 @@
   <p:extLst>
     <p:ext uri="{521415D9-36F7-43E2-AB2F-B90AF26B5E84}">
       <p14:sectionLst xmlns:p14="http://schemas.microsoft.com/office/powerpoint/2010/main">
-        <p14:section name="Opening" id="{e9f32e46-5cce-d3e0-1a47-1e9b4d1efeea}">
+        <p14:section name="Opening" id="{a0b407fb-7976-054a-bed4-c80fb637a218}">
           <p14:sldIdLst>
             <p14:sldId id="256"/>
             <p14:sldId id="257"/>
           </p14:sldIdLst>
         </p14:section>
-        <p14:section name="Problem and approach" id="{9d38b4db-6c16-6d52-c047-ea45597019ed}">
+        <p14:section name="Problem and approach" id="{8852ca1e-0760-5a78-6174-efdf1f89da96}">
           <p14:sldIdLst>
             <p14:sldId id="258"/>
             <p14:sldId id="259"/>
           </p14:sldIdLst>
         </p14:section>
-        <p14:section name="Key insights" id="{d688c42a-1a10-07e5-d541-edfb80ce9baf}">
+        <p14:section name="Key insights" id="{c5e05691-4be5-7c78-28dc-e5a0c661318e}">
           <p14:sldIdLst>
             <p14:sldId id="260"/>
             <p14:sldId id="261"/>
             <p14:sldId id="262"/>
           </p14:sldIdLst>
         </p14:section>
-        <p14:section name="Modelling" id="{bbe3d4e1-4dfa-02e6-e325-602865790267}">
+        <p14:section name="Modelling" id="{7b3597a8-3463-ffaa-5de6-914e7c7bbe61}">
           <p14:sldIdLst>
             <p14:sldId id="263"/>
             <p14:sldId id="264"/>
@@ -152,7 +152,7 @@
             <p14:sldId id="266"/>
           </p14:sldIdLst>
         </p14:section>
-        <p14:section name="Recommendations" id="{21924011-da29-d5e4-21b5-4fa2a1e783a6}">
+        <p14:section name="Recommendations" id="{41a1dd9a-8f68-57ec-fa26-a513904c674d}">
           <p14:sldIdLst>
             <p14:sldId id="267"/>
             <p14:sldId id="268"/>
@@ -160,7 +160,7 @@
             <p14:sldId id="270"/>
           </p14:sldIdLst>
         </p14:section>
-        <p14:section name="Appendix" id="{4c3f13bf-1fec-2ba4-4d08-2a8210c80d34}">
+        <p14:section name="Appendix" id="{f5ed4a6e-f6a5-0665-d738-ff4909fc6255}">
           <p14:sldIdLst>
             <p14:sldId id="271"/>
             <p14:sldId id="272"/>
@@ -6156,7 +6156,7 @@
                   <a:srgbClr val="1E2761"/>
                 </a:solidFill>
               </a:rPr>
-              <a:t>Proposed solution: a Random Forest scorer with a Decision Tree explanation layer</a:t>
+              <a:t>Proposed solution: a Random Forest scorer explained by a surrogate decision tree</a:t>
             </a:r>
             <a:endParaRPr lang="en-US" sz="2400" dirty="0"/>
           </a:p>
@@ -6555,7 +6555,7 @@
       </p:sp>
       <p:sp>
         <p:nvSpPr>
-          <p:cNvPr id="12" name="stat 90%"/>
+          <p:cNvPr id="12" name="stat 89%"/>
           <p:cNvSpPr txBox="1"/>
           <p:nvPr/>
         </p:nvSpPr>
@@ -6583,7 +6583,7 @@
                   <a:schemeClr val="accent1"/>
                 </a:solidFill>
               </a:rPr>
-              <a:t>90%</a:t>
+              <a:t>89%</a:t>
             </a:r>
             <a:endParaRPr lang="en-US" sz="3400" dirty="0"/>
           </a:p>
@@ -16137,14 +16137,14 @@
               <a:buChar char="•"/>
             </a:pPr>
             <a:r>
-              <a:rPr lang="en-US" sz="1200" dirty="0">
+              <a:rPr lang="en-US" sz="1100" dirty="0">
                 <a:solidFill>
                   <a:schemeClr val="tx1"/>
                 </a:solidFill>
               </a:rPr>
-              <a:t>The debt-to-income ratio and its missing flag carry more than a third (36%) of the final forest's decision power; with delinquent lines and credit-history length, about half.</a:t>
+              <a:t>The debt-to-income ratio and its missing flag carry 36% of the final forest's decision power; with delinquent lines and credit-history length, about half.</a:t>
             </a:r>
-            <a:endParaRPr lang="en-US" sz="1200" dirty="0"/>
+            <a:endParaRPr lang="en-US" sz="1100" dirty="0"/>
           </a:p>
           <a:p>
             <a:pPr marL="177800" indent="-177800">
@@ -16155,14 +16155,14 @@
               <a:buChar char="•"/>
             </a:pPr>
             <a:r>
-              <a:rPr lang="en-US" sz="1200" dirty="0">
+              <a:rPr lang="en-US" sz="1100" dirty="0">
                 <a:solidFill>
                   <a:schemeClr val="tx1"/>
                 </a:solidFill>
               </a:rPr>
-              <a:t>Permutation importance (drop in ranking quality when a column is shuffled) ranks the same four at the top, with delinquent credit lines first.</a:t>
+              <a:t>Permutation importance (drop in ranking quality when a column is shuffled) ranks the same four at the top, delinquent credit lines first.</a:t>
             </a:r>
-            <a:endParaRPr lang="en-US" sz="1200" dirty="0"/>
+            <a:endParaRPr lang="en-US" sz="1100" dirty="0"/>
           </a:p>
           <a:p>
             <a:pPr marL="177800" indent="-177800">
@@ -16173,14 +16173,14 @@
               <a:buChar char="•"/>
             </a:pPr>
             <a:r>
-              <a:rPr lang="en-US" sz="1200" dirty="0">
+              <a:rPr lang="en-US" sz="1100" dirty="0">
                 <a:solidFill>
                   <a:schemeClr val="tx1"/>
                 </a:solidFill>
               </a:rPr>
-              <a:t>Loan, property and mortgage amounts matter in combination but are weak on their own.</a:t>
+              <a:t>Loan, property and mortgage amounts matter in combination, little on their own.</a:t>
             </a:r>
-            <a:endParaRPr lang="en-US" sz="1200" dirty="0"/>
+            <a:endParaRPr lang="en-US" sz="1100" dirty="0"/>
           </a:p>
           <a:p>
             <a:pPr marL="177800" indent="-177800">
@@ -16191,14 +16191,14 @@
               <a:buChar char="•"/>
             </a:pPr>
             <a:r>
-              <a:rPr lang="en-US" sz="1200" dirty="0">
+              <a:rPr lang="en-US" sz="1100" dirty="0">
                 <a:solidFill>
                   <a:schemeClr val="tx1"/>
                 </a:solidFill>
               </a:rPr>
-              <a:t>Occupation, loan-purpose and minor missing flags matter little individually, yet dropping them raised out-of-fold expected cost by about a sixth, so they stay subject to the fair-lending review.</a:t>
+              <a:t>Occupation, loan purpose and minor flags matter little individually, yet dropping them raised out-of-fold expected cost by about a sixth, so they stay subject to the fair-lending review.</a:t>
             </a:r>
-            <a:endParaRPr lang="en-US" sz="1200" dirty="0"/>
+            <a:endParaRPr lang="en-US" sz="1100" dirty="0"/>
           </a:p>
           <a:p>
             <a:pPr marL="177800" indent="-177800">
@@ -16209,14 +16209,14 @@
               <a:buChar char="•"/>
             </a:pPr>
             <a:r>
-              <a:rPr lang="en-US" sz="1200" dirty="0">
+              <a:rPr lang="en-US" sz="1100" dirty="0">
                 <a:solidFill>
                   <a:schemeClr val="tx1"/>
                 </a:solidFill>
               </a:rPr>
-              <a:t>Logistic-regression coefficients, the decision-tree rules and the surrogate tree point to the same drivers, so the signal is stable across techniques.</a:t>
+              <a:t>Logistic-regression coefficients, tree rules and the surrogate tree all point to the same drivers.</a:t>
             </a:r>
-            <a:endParaRPr lang="en-US" sz="1200" dirty="0"/>
+            <a:endParaRPr lang="en-US" sz="1100" dirty="0"/>
           </a:p>
         </p:txBody>
       </p:sp>
@@ -21543,7 +21543,7 @@
                   <a:schemeClr val="tx1"/>
                 </a:solidFill>
               </a:rPr>
-              <a:t>Bank loses most of the principal plus collection cost: about $9,000 on a typical $18,600 loan.</a:t>
+              <a:t>Bank loses most of the principal plus collection cost: about $9,000 on a typical $16,900 defaulted loan.</a:t>
             </a:r>
             <a:endParaRPr lang="en-US" sz="1200" dirty="0"/>
           </a:p>

</xml_diff>

<commit_message>
Resolve the last three verification notes (fair-lending mitigation, 3+ derogatory rate, surrogate rule wording)
Co-Authored-By: Claude Fable 5.1 <noreply@anthropic.com>
Claude-Session: https://claude.ai/code/session_013FziBHdvbXYQwd5XRG4tZw
</commit_message>
<xml_diff>
--- a/presentation/Loan_Default_Prediction_Presentation.pptx
+++ b/presentation/Loan_Default_Prediction_Presentation.pptx
@@ -125,26 +125,26 @@
   <p:extLst>
     <p:ext uri="{521415D9-36F7-43E2-AB2F-B90AF26B5E84}">
       <p14:sectionLst xmlns:p14="http://schemas.microsoft.com/office/powerpoint/2010/main">
-        <p14:section name="Opening" id="{a0b407fb-7976-054a-bed4-c80fb637a218}">
+        <p14:section name="Opening" id="{37de1b48-ac53-7ec6-04b8-dca1473fde2e}">
           <p14:sldIdLst>
             <p14:sldId id="256"/>
             <p14:sldId id="257"/>
           </p14:sldIdLst>
         </p14:section>
-        <p14:section name="Problem and approach" id="{8852ca1e-0760-5a78-6174-efdf1f89da96}">
+        <p14:section name="Problem and approach" id="{ac8bfee5-f84f-1fc3-0094-da35085e4ed7}">
           <p14:sldIdLst>
             <p14:sldId id="258"/>
             <p14:sldId id="259"/>
           </p14:sldIdLst>
         </p14:section>
-        <p14:section name="Key insights" id="{c5e05691-4be5-7c78-28dc-e5a0c661318e}">
+        <p14:section name="Key insights" id="{44915eb0-19fa-5373-41b2-8bd07b656af0}">
           <p14:sldIdLst>
             <p14:sldId id="260"/>
             <p14:sldId id="261"/>
             <p14:sldId id="262"/>
           </p14:sldIdLst>
         </p14:section>
-        <p14:section name="Modelling" id="{7b3597a8-3463-ffaa-5de6-914e7c7bbe61}">
+        <p14:section name="Modelling" id="{8f8a1990-512d-0021-2c5b-f8cec339d339}">
           <p14:sldIdLst>
             <p14:sldId id="263"/>
             <p14:sldId id="264"/>
@@ -152,7 +152,7 @@
             <p14:sldId id="266"/>
           </p14:sldIdLst>
         </p14:section>
-        <p14:section name="Recommendations" id="{41a1dd9a-8f68-57ec-fa26-a513904c674d}">
+        <p14:section name="Recommendations" id="{a1e64938-fa53-f4b3-c3b1-9ffbc78f19f4}">
           <p14:sldIdLst>
             <p14:sldId id="267"/>
             <p14:sldId id="268"/>
@@ -160,7 +160,7 @@
             <p14:sldId id="270"/>
           </p14:sldIdLst>
         </p14:section>
-        <p14:section name="Appendix" id="{f5ed4a6e-f6a5-0665-d738-ff4909fc6255}">
+        <p14:section name="Appendix" id="{92693547-47b2-2b2a-80db-050972555ab0}">
           <p14:sldIdLst>
             <p14:sldId id="271"/>
             <p14:sldId id="272"/>
@@ -17079,7 +17079,7 @@
                   <a:schemeClr val="tx1"/>
                 </a:solidFill>
               </a:rPr>
-              <a:t>Small loans with an unverified ratio are flagged; the loan amount refines borderline cases.</a:t>
+              <a:t>Appears as a split under an unverified ratio and short history, but every applicant on that path is flagged whatever the amount; the amount does not change the decision at this depth.</a:t>
             </a:r>
             <a:endParaRPr lang="en-US" sz="1200" dirty="0"/>
           </a:p>
@@ -21083,7 +21083,7 @@
                   <a:schemeClr val="tx1"/>
                 </a:solidFill>
               </a:rPr>
-              <a:t>Between a 20% and a 40% ratio only 4-7% default; above 45% almost everyone does. Each delinquent line or derogatory report roughly doubles the risk (0 reports: 17%, 1: 39%, 2: 51%, 3+: about 73%). Both are plain-language rules an applicant can be given.</a:t>
+              <a:t>Between a 20% and a 40% ratio only 4-7% default; above 45% almost everyone does. Each delinquent line or derogatory report roughly doubles the risk (0 reports: 17%, 1: 39%, 2: 51%, 3+: about 75%). Both are plain-language rules an applicant can be given.</a:t>
             </a:r>
             <a:endParaRPr lang="en-US" sz="1200" dirty="0"/>
           </a:p>

</xml_diff>

<commit_message>
Apply earlier learnings to the remaining spots: simple tense, class-weight wording in the low-code notebook, no semicolon in a deck label
Co-Authored-By: Claude Opus 5.5 <noreply@anthropic.com>
Claude-Session: https://claude.ai/code/session_013FziBHdvbXYQwd5XRG4tZw
</commit_message>
<xml_diff>
--- a/presentation/Loan_Default_Prediction_Presentation.pptx
+++ b/presentation/Loan_Default_Prediction_Presentation.pptx
@@ -125,26 +125,26 @@
   <p:extLst>
     <p:ext uri="{521415D9-36F7-43E2-AB2F-B90AF26B5E84}">
       <p14:sectionLst xmlns:p14="http://schemas.microsoft.com/office/powerpoint/2010/main">
-        <p14:section name="Opening" id="{024872b7-6347-1176-c108-1a6c5df5e5e9}">
+        <p14:section name="Opening" id="{26b4bff5-d502-a538-1ab2-91c5de606850}">
           <p14:sldIdLst>
             <p14:sldId id="256"/>
             <p14:sldId id="257"/>
           </p14:sldIdLst>
         </p14:section>
-        <p14:section name="Problem and approach" id="{3c3469b8-a23c-0f4f-30d4-ca2009c7e98d}">
+        <p14:section name="Problem and approach" id="{07013b1c-fdbb-0eba-9175-e32c77e209b9}">
           <p14:sldIdLst>
             <p14:sldId id="258"/>
             <p14:sldId id="259"/>
           </p14:sldIdLst>
         </p14:section>
-        <p14:section name="Key insights" id="{29298f19-d98a-9751-ef4e-5137f4b61733}">
+        <p14:section name="Key insights" id="{44898d68-4f9f-c501-4c89-5ed46a3b47de}">
           <p14:sldIdLst>
             <p14:sldId id="260"/>
             <p14:sldId id="261"/>
             <p14:sldId id="262"/>
           </p14:sldIdLst>
         </p14:section>
-        <p14:section name="Modelling" id="{7d01b399-d63f-6834-28b7-33db6f38b6ed}">
+        <p14:section name="Modelling" id="{fdb1327d-4aac-26a6-0494-8c252398247f}">
           <p14:sldIdLst>
             <p14:sldId id="263"/>
             <p14:sldId id="264"/>
@@ -152,7 +152,7 @@
             <p14:sldId id="266"/>
           </p14:sldIdLst>
         </p14:section>
-        <p14:section name="Recommendations" id="{1a560e43-1db7-195c-1d4f-f33ca76b414f}">
+        <p14:section name="Recommendations" id="{7d809f85-6544-e076-0c1e-191b39603eb6}">
           <p14:sldIdLst>
             <p14:sldId id="267"/>
             <p14:sldId id="268"/>
@@ -160,7 +160,7 @@
             <p14:sldId id="270"/>
           </p14:sldIdLst>
         </p14:section>
-        <p14:section name="Appendix" id="{ad62cb44-cad2-0677-bb70-513f158d669f}">
+        <p14:section name="Appendix" id="{12bbe9fc-a2d1-f086-4b5d-14fa725e3ad2}">
           <p14:sldIdLst>
             <p14:sldId id="271"/>
             <p14:sldId id="272"/>
@@ -2143,7 +2143,7 @@
                     <c:v>Bagged trees (200)</c:v>
                   </c:pt>
                   <c:pt idx="3">
-                    <c:v>Random Forest (default; proposed at 0.5)</c:v>
+                    <c:v>Random Forest (default: proposed model at 0.5)</c:v>
                   </c:pt>
                   <c:pt idx="4">
                     <c:v>Random Forest (class weights)</c:v>
@@ -2244,7 +2244,7 @@
                     <c:v>Bagged trees (200)</c:v>
                   </c:pt>
                   <c:pt idx="3">
-                    <c:v>Random Forest (default; proposed at 0.5)</c:v>
+                    <c:v>Random Forest (default: proposed model at 0.5)</c:v>
                   </c:pt>
                   <c:pt idx="4">
                     <c:v>Random Forest (class weights)</c:v>

</xml_diff>

<commit_message>
Make input-set reduction explicit and rule-based across all deliverables
Apply the earlier project feedback on dimensionality reduction: name every
input at each pipeline stage, state the rule that picks the input set (the
smallest set within one standard error of the lowest out-of-fold cost) and
name the 21- and 12-input sets that the rule rejects.

- Notebooks: LR input printout, a model-inputs-by-stage table, and a
  final-pipeline step that applies the reduction rule to the named sets
- Milestone Report: new "Model inputs" treatment bullet and a rewritten
  "Simpler models cost more" paragraph
- Final Report, deck Appendix D and README: name the reduced sets and the rule

Co-Authored-By: Claude Opus 5.5 <noreply@anthropic.com>
Claude-Session: https://claude.ai/code/session_013FziBHdvbXYQwd5XRG4tZw
</commit_message>
<xml_diff>
--- a/presentation/Loan_Default_Prediction_Presentation.pptx
+++ b/presentation/Loan_Default_Prediction_Presentation.pptx
@@ -125,26 +125,26 @@
   <p:extLst>
     <p:ext uri="{521415D9-36F7-43E2-AB2F-B90AF26B5E84}">
       <p14:sectionLst xmlns:p14="http://schemas.microsoft.com/office/powerpoint/2010/main">
-        <p14:section name="Opening" id="{a7f826f0-1d36-ae61-6541-eb9d3fbe70db}">
+        <p14:section name="Opening" id="{38c4bc4e-2915-2a87-b841-446367403869}">
           <p14:sldIdLst>
             <p14:sldId id="256"/>
             <p14:sldId id="257"/>
           </p14:sldIdLst>
         </p14:section>
-        <p14:section name="Problem and approach" id="{368fc12e-f32b-ea89-db37-afccd7554805}">
+        <p14:section name="Problem and approach" id="{b321e987-0aff-7844-b0cc-2b3942438861}">
           <p14:sldIdLst>
             <p14:sldId id="258"/>
             <p14:sldId id="259"/>
           </p14:sldIdLst>
         </p14:section>
-        <p14:section name="Key insights" id="{2ec2be44-89c2-78f7-ed66-827689e9557b}">
+        <p14:section name="Key insights" id="{5632ece6-e2a5-ce98-7a0a-b8a4fd66bd13}">
           <p14:sldIdLst>
             <p14:sldId id="260"/>
             <p14:sldId id="261"/>
             <p14:sldId id="262"/>
           </p14:sldIdLst>
         </p14:section>
-        <p14:section name="Modelling" id="{c4a2f653-b9ad-e94e-74d5-85153b76eae2}">
+        <p14:section name="Modelling" id="{113d6635-5758-bcbf-3157-d78d9cf98f23}">
           <p14:sldIdLst>
             <p14:sldId id="263"/>
             <p14:sldId id="264"/>
@@ -152,7 +152,7 @@
             <p14:sldId id="266"/>
           </p14:sldIdLst>
         </p14:section>
-        <p14:section name="Recommendations" id="{53d25c27-e281-58f0-f06d-e49182df7018}">
+        <p14:section name="Recommendations" id="{8ea0698d-341c-6881-8e58-27ab8191cf38}">
           <p14:sldIdLst>
             <p14:sldId id="267"/>
             <p14:sldId id="268"/>
@@ -160,7 +160,7 @@
             <p14:sldId id="270"/>
           </p14:sldIdLst>
         </p14:section>
-        <p14:section name="Appendix" id="{01266bd1-2a0e-f19d-bab9-3995f3ef9572}">
+        <p14:section name="Appendix" id="{cbbb411e-e37b-827c-95f7-b36e804b4a75}">
           <p14:sldIdLst>
             <p14:sldId id="271"/>
             <p14:sldId id="272"/>
@@ -18828,7 +18828,7 @@
                           <a:ea typeface="Calibri" pitchFamily="34" charset="-122"/>
                           <a:cs typeface="Calibri" pitchFamily="34" charset="-120"/>
                         </a:rPr>
-                        <a:t>The notebook's final-pipeline cell names every input to the final model, with the imputation values and model settings</a:t>
+                        <a:t>The final-pipeline cell names every input. Smaller sets cost more out of fold (21 inputs without occupation +10%, 12 inputs +19%), so all 27 stay</a:t>
                       </a:r>
                       <a:endParaRPr lang="en-US" sz="950" dirty="0">
                         <a:latin typeface="Calibri" charset="0"/>

</xml_diff>

<commit_message>
Fix consistency findings after the switch to 22 inputs
- Call the $1.8m-to-$0.3m figure the cost of credit errors everywhere, not
  the default-related cost (Final Report, deck slide 2 and notes, low-code
  notebook)
- State that the other-splits check chose 0.15 for the unweighted 27-input
  forest, and no longer imply it covered the 22-input model
- "Every fully grown forest in Stage 1 and Stage 3" (the 10-input forest
  in the Stage 2 curve costs more than bagging)
- Low-code recall range 71% to 94%, 84 good applicants declined at 0.20,
  "12-input set" everywhere, shorter Stage 2 sentences, model-inputs table
  uses "step" so it does not clash with the selection stages, and the
  EDA-drivers table notes the surrogate's JOB_missing split

Co-Authored-By: Claude Opus 5.5 <noreply@anthropic.com>
Claude-Session: https://claude.ai/code/session_013FziBHdvbXYQwd5XRG4tZw
</commit_message>
<xml_diff>
--- a/presentation/Loan_Default_Prediction_Presentation.pptx
+++ b/presentation/Loan_Default_Prediction_Presentation.pptx
@@ -125,26 +125,26 @@
   <p:extLst>
     <p:ext uri="{521415D9-36F7-43E2-AB2F-B90AF26B5E84}">
       <p14:sectionLst xmlns:p14="http://schemas.microsoft.com/office/powerpoint/2010/main">
-        <p14:section name="Opening" id="{4bd73a43-34e0-c8c7-d7de-0e125493f825}">
+        <p14:section name="Opening" id="{a4457d1a-2bbf-3295-7f76-2787341740c4}">
           <p14:sldIdLst>
             <p14:sldId id="256"/>
             <p14:sldId id="257"/>
           </p14:sldIdLst>
         </p14:section>
-        <p14:section name="Problem and approach" id="{2dc41030-6da8-2a51-ad2a-17cd48bdcd8a}">
+        <p14:section name="Problem and approach" id="{65714d2d-2070-d04c-29a1-6ae6acb1db49}">
           <p14:sldIdLst>
             <p14:sldId id="258"/>
             <p14:sldId id="259"/>
           </p14:sldIdLst>
         </p14:section>
-        <p14:section name="Key insights" id="{e1789cb2-adee-278c-4cc3-96e3b7e0bc92}">
+        <p14:section name="Key insights" id="{c345ab57-e9ee-41ba-dde8-e8d9535996b0}">
           <p14:sldIdLst>
             <p14:sldId id="260"/>
             <p14:sldId id="261"/>
             <p14:sldId id="262"/>
           </p14:sldIdLst>
         </p14:section>
-        <p14:section name="Modelling" id="{73805249-8449-dbaf-d53f-15d67b4d9db0}">
+        <p14:section name="Modelling" id="{ce4cde7c-b9cd-6a0c-d7c3-7a0aff6c154a}">
           <p14:sldIdLst>
             <p14:sldId id="263"/>
             <p14:sldId id="264"/>
@@ -152,7 +152,7 @@
             <p14:sldId id="266"/>
           </p14:sldIdLst>
         </p14:section>
-        <p14:section name="Recommendations" id="{6e40bfff-3293-bf34-89f9-8e5a02edd23e}">
+        <p14:section name="Recommendations" id="{3aba29f0-69ab-701d-1e20-7bd2db4f8d54}">
           <p14:sldIdLst>
             <p14:sldId id="267"/>
             <p14:sldId id="268"/>
@@ -160,7 +160,7 @@
             <p14:sldId id="270"/>
           </p14:sldIdLst>
         </p14:section>
-        <p14:section name="Appendix" id="{71f734e1-526b-6809-5fdf-ba3f4c5f5e7d}">
+        <p14:section name="Appendix" id="{fe9ebe8a-b7e9-d0b6-0c75-f5f244f4bc54}">
           <p14:sldIdLst>
             <p14:sldId id="271"/>
             <p14:sldId id="272"/>
@@ -3747,7 +3747,7 @@
           <a:p>
             <a:r>
               <a:rPr lang="en-US" dirty="0"/>
-              <a:t>Good morning. In the next eight minutes I will show how a bank can cut the default-related cost of the home equity loans it approves today. The cut is about four fifths, with a model the bank can also explain to regulators and applicants.</a:t>
+              <a:t>Good morning. In eight minutes I will show how a bank can cut the cost of credit errors on the home equity loans it approves today. The cut is about four fifths, with a model the bank can also explain to regulators and applicants.</a:t>
             </a:r>
             <a:endParaRPr lang="en-US" dirty="0"/>
           </a:p>
@@ -4011,7 +4011,7 @@
           <a:p>
             <a:r>
               <a:rPr lang="en-US" dirty="0"/>
-              <a:t>With round-number assumptions, the bank's default-related cost falls from about 10.8 million to about 1.9 million a year on 6,000 applications. Even if the real benefit were a quarter of that, the project repays its cost inside a year. Finance should replace these assumptions with actual loss and margin figures.</a:t>
+              <a:t>With round-number assumptions, the bank's cost of credit errors falls from about 10.8 million to about 1.9 million a year on 6,000 applications. Even if the real benefit were a quarter of that, the project repays its cost inside a year. Finance should replace these assumptions with actual loss and margin figures.</a:t>
             </a:r>
             <a:endParaRPr lang="en-US" dirty="0"/>
           </a:p>
@@ -6331,7 +6331,7 @@
                   <a:schemeClr val="tx1"/>
                 </a:solidFill>
               </a:rPr>
-              <a:t>Threshold 0.15, chosen with the configuration on repeated out-of-fold expected cost (training rows). It holds for cost ratios 4.5:1 to 8:1 and across splits. Approve / refer / decline bands (69% / 7% / 24%) keep an underwriter in the loop.</a:t>
+              <a:t>Threshold 0.15, chosen with the configuration on repeated out-of-fold expected cost (training rows). It holds for cost ratios 4.5:1 to 8:1 and on a finer grid. Approve / refer / decline bands (69% / 7% / 24%) keep an underwriter in the loop.</a:t>
             </a:r>
             <a:endParaRPr lang="en-US" sz="1100" dirty="0"/>
           </a:p>
@@ -7129,7 +7129,7 @@
                   <a:schemeClr val="accent6"/>
                 </a:solidFill>
               </a:rPr>
-              <a:t>Curves: out-of-fold predictions on the training rows. Cards: test set, per 1,000 applicants, at $9,000 per missed defaulter and $2,000 per wrongly declined customer. The optimum stays at 0.15 for cost ratios 4.5:1 to 8:1 and on other splits.</a:t>
+              <a:t>Curves: out-of-fold predictions on the training rows. Cards: test set, per 1,000 applicants, at $9,000 per missed defaulter and $2,000 per wrongly declined customer. The optimum stays at 0.15 for cost ratios 4.5:1 to 8:1 and on a finer grid.</a:t>
             </a:r>
             <a:endParaRPr lang="en-US" sz="900" dirty="0"/>
           </a:p>
@@ -19407,7 +19407,7 @@
                   <a:schemeClr val="tx1"/>
                 </a:solidFill>
               </a:rPr>
-              <a:t>indicative annual benefit on 6,000 applications, from roughly $10.8M of default-related cost down to about $1.9M.</a:t>
+              <a:t>indicative annual benefit on 6,000 applications, from roughly $10.8M of credit-error cost down to about $1.9M.</a:t>
             </a:r>
             <a:endParaRPr lang="en-US" sz="1200" dirty="0"/>
           </a:p>

</xml_diff>

<commit_message>
Close the remaining rubric gaps in both milestone deliverables
Full-code notebook:
- C3: the Model Building approach now justifies the techniques from four
  EDA facts, and says why k-nearest neighbours and SVMs were left out
- C3: the suggested engineered features each name the pattern they capture
- C4: an explicit "Which technique performs relatively better?" answer
  with the reason, and a corrected similar-recall comparison
- Guidelines: a labelled list of six business recommendations, and a
  leading comment on the precision-recall cell

Milestone Report:
- C5: new "How the solution solves the problem" subsection that maps the
  design to the four objectives in Section 1
- C3 and C4: data reasons for the engineered features and a corrected
  similar-recall comparison

Co-Authored-By: Claude Opus 5.5 <noreply@anthropic.com>
Claude-Session: https://claude.ai/code/session_013FziBHdvbXYQwd5XRG4tZw
</commit_message>
<xml_diff>
--- a/presentation/Loan_Default_Prediction_Presentation.pptx
+++ b/presentation/Loan_Default_Prediction_Presentation.pptx
@@ -125,26 +125,26 @@
   <p:extLst>
     <p:ext uri="{521415D9-36F7-43E2-AB2F-B90AF26B5E84}">
       <p14:sectionLst xmlns:p14="http://schemas.microsoft.com/office/powerpoint/2010/main">
-        <p14:section name="Opening" id="{a4457d1a-2bbf-3295-7f76-2787341740c4}">
+        <p14:section name="Opening" id="{e7d45f88-3d9c-75b4-4a2d-ceb0cccf3c9d}">
           <p14:sldIdLst>
             <p14:sldId id="256"/>
             <p14:sldId id="257"/>
           </p14:sldIdLst>
         </p14:section>
-        <p14:section name="Problem and approach" id="{65714d2d-2070-d04c-29a1-6ae6acb1db49}">
+        <p14:section name="Problem and approach" id="{dbf21325-3608-0ad1-f644-01aa8ae75c6a}">
           <p14:sldIdLst>
             <p14:sldId id="258"/>
             <p14:sldId id="259"/>
           </p14:sldIdLst>
         </p14:section>
-        <p14:section name="Key insights" id="{c345ab57-e9ee-41ba-dde8-e8d9535996b0}">
+        <p14:section name="Key insights" id="{32af3488-d75d-73ec-ad51-5b8ccaed7542}">
           <p14:sldIdLst>
             <p14:sldId id="260"/>
             <p14:sldId id="261"/>
             <p14:sldId id="262"/>
           </p14:sldIdLst>
         </p14:section>
-        <p14:section name="Modelling" id="{ce4cde7c-b9cd-6a0c-d7c3-7a0aff6c154a}">
+        <p14:section name="Modelling" id="{fd826df0-1a0c-9fc8-f654-8ee32c33d7e5}">
           <p14:sldIdLst>
             <p14:sldId id="263"/>
             <p14:sldId id="264"/>
@@ -152,7 +152,7 @@
             <p14:sldId id="266"/>
           </p14:sldIdLst>
         </p14:section>
-        <p14:section name="Recommendations" id="{3aba29f0-69ab-701d-1e20-7bd2db4f8d54}">
+        <p14:section name="Recommendations" id="{95bab55f-c5db-b28a-437e-2bb15f710fdf}">
           <p14:sldIdLst>
             <p14:sldId id="267"/>
             <p14:sldId id="268"/>
@@ -160,7 +160,7 @@
             <p14:sldId id="270"/>
           </p14:sldIdLst>
         </p14:section>
-        <p14:section name="Appendix" id="{fe9ebe8a-b7e9-d0b6-0c75-f5f244f4bc54}">
+        <p14:section name="Appendix" id="{750fd132-63cd-034f-47b0-3364360a719b}">
           <p14:sldIdLst>
             <p14:sldId id="271"/>
             <p14:sldId id="272"/>

</xml_diff>

<commit_message>
Apply the last consistency fixes to the reports, deck and low-code labels
- Milestone Table 2 and the Final Report name exactly what the 12-input
  set removes (the six occupation and loan-purpose indicators and nine of
  the eleven missing flags)
- Slide 11 notes: the other-splits check chose 0.15 for the 27-input forest
- Low-code robustness checks are now labelled (a) to (e) in run order; the
  re-executed notebook follows in the next commit

Co-Authored-By: Claude Opus 5.5 <noreply@anthropic.com>
Claude-Session: https://claude.ai/code/session_013FziBHdvbXYQwd5XRG4tZw
</commit_message>
<xml_diff>
--- a/presentation/Loan_Default_Prediction_Presentation.pptx
+++ b/presentation/Loan_Default_Prediction_Presentation.pptx
@@ -125,26 +125,26 @@
   <p:extLst>
     <p:ext uri="{521415D9-36F7-43E2-AB2F-B90AF26B5E84}">
       <p14:sectionLst xmlns:p14="http://schemas.microsoft.com/office/powerpoint/2010/main">
-        <p14:section name="Opening" id="{e7d45f88-3d9c-75b4-4a2d-ceb0cccf3c9d}">
+        <p14:section name="Opening" id="{610fd71e-f313-a676-6eae-468d4deb3d06}">
           <p14:sldIdLst>
             <p14:sldId id="256"/>
             <p14:sldId id="257"/>
           </p14:sldIdLst>
         </p14:section>
-        <p14:section name="Problem and approach" id="{dbf21325-3608-0ad1-f644-01aa8ae75c6a}">
+        <p14:section name="Problem and approach" id="{d4965090-96e4-2995-e04b-0be61a68496c}">
           <p14:sldIdLst>
             <p14:sldId id="258"/>
             <p14:sldId id="259"/>
           </p14:sldIdLst>
         </p14:section>
-        <p14:section name="Key insights" id="{32af3488-d75d-73ec-ad51-5b8ccaed7542}">
+        <p14:section name="Key insights" id="{9bf446a5-6f47-dd97-5a11-d880afca0b8a}">
           <p14:sldIdLst>
             <p14:sldId id="260"/>
             <p14:sldId id="261"/>
             <p14:sldId id="262"/>
           </p14:sldIdLst>
         </p14:section>
-        <p14:section name="Modelling" id="{fd826df0-1a0c-9fc8-f654-8ee32c33d7e5}">
+        <p14:section name="Modelling" id="{ae499c8a-c989-4f16-1976-d3aea65c27d0}">
           <p14:sldIdLst>
             <p14:sldId id="263"/>
             <p14:sldId id="264"/>
@@ -152,7 +152,7 @@
             <p14:sldId id="266"/>
           </p14:sldIdLst>
         </p14:section>
-        <p14:section name="Recommendations" id="{95bab55f-c5db-b28a-437e-2bb15f710fdf}">
+        <p14:section name="Recommendations" id="{ad930b30-243a-2648-756a-abd734ce40dd}">
           <p14:sldIdLst>
             <p14:sldId id="267"/>
             <p14:sldId id="268"/>
@@ -160,7 +160,7 @@
             <p14:sldId id="270"/>
           </p14:sldIdLst>
         </p14:section>
-        <p14:section name="Appendix" id="{750fd132-63cd-034f-47b0-3364360a719b}">
+        <p14:section name="Appendix" id="{63bb47e9-56a9-e499-9a6a-58286cbaeb55}">
           <p14:sldIdLst>
             <p14:sldId id="271"/>
             <p14:sldId id="272"/>
@@ -3923,7 +3923,7 @@
           <a:p>
             <a:r>
               <a:rPr lang="en-US" dirty="0"/>
-              <a:t>The model outputs a probability, and 0.5 is only a convention. We chose the threshold on out-of-fold predictions of the training rows, so the test set played no part. Moving it to 0.15 cuts missed defaulters from 64 to 15 per thousand applicants on the test set. The price is flagging 90 instead of 28 good customers. It is the cheapest operating point for any cost ratio between four and a half and eight to one. Our assumed ratio of four and a half to one sits at the lower edge of that range. It held on a finer grid and on other train/test splits. It sits just below the textbook break-even of 0.18 for a perfectly calibrated score, because the forest's scores understate risk in the decision range. Applicants scored fifteen to twenty percent defaulted about twenty-eight percent of the time.</a:t>
+              <a:t>The model outputs a probability, and 0.5 is only a convention. We chose the threshold on out-of-fold predictions of the training rows, so the test set played no part. Moving it to 0.15 cuts missed defaulters from 64 to 15 per thousand applicants on the test set. The price is flagging 90 instead of 28 good customers. It is the cheapest operating point for any cost ratio between four and a half and eight to one. Our assumed ratio of four and a half to one sits at the lower edge of that range. It held on a finer grid. On two other train/test splits, the 27-input forest also chose 0.15. It sits just below the textbook break-even of 0.18 for a perfectly calibrated score, because the forest's scores understate risk in the decision range. Applicants scored fifteen to twenty percent defaulted about twenty-eight percent of the time.</a:t>
             </a:r>
             <a:endParaRPr lang="en-US" dirty="0"/>
           </a:p>

</xml_diff>